<commit_message>
Presentación: créditos y contactos fijos en el pie de todas las láminas
- Cada lámina (web, PDF y PowerPoint) lleva "Elaborado por" y
  "Dudas/consultas" en un pie fijo, con el número de página.
- En pantalla el pie queda siempre debajo del contenido (la lámina crece si
  hace falta) y en celulares no se superpone.
- Se quita el bloque duplicado de créditos del cuerpo de portada y cierre.

Co-Authored-By: Claude Opus 5.5 <noreply@anthropic.com>
Claude-Session: https://claude.ai/code/session_01HwS5TWbDP37WWanbk4LKQ2
</commit_message>
<xml_diff>
--- a/Presupuesto_2027_SOFSA_presentacion.pptx
+++ b/Presupuesto_2027_SOFSA_presentacion.pptx
@@ -4906,8 +4906,8 @@
         </p:nvSpPr>
         <p:spPr>
           <a:xfrm>
-            <a:off x="57150" y="114300"/>
-            <a:ext cx="10582275" cy="7391400"/>
+            <a:off x="0" y="57150"/>
+            <a:ext cx="10696575" cy="7505700"/>
           </a:xfrm>
           <a:prstGeom prst="rect">
             <a:avLst/>
@@ -4926,8 +4926,8 @@
         </p:nvSpPr>
         <p:spPr>
           <a:xfrm>
-            <a:off x="628650" y="2054721"/>
-            <a:ext cx="9820275" cy="177165"/>
+            <a:off x="571500" y="2392859"/>
+            <a:ext cx="9934575" cy="177165"/>
           </a:xfrm>
           <a:prstGeom prst="rect">
             <a:avLst/>
@@ -4968,8 +4968,8 @@
         </p:nvSpPr>
         <p:spPr>
           <a:xfrm>
-            <a:off x="628650" y="2327077"/>
-            <a:ext cx="9820275" cy="885825"/>
+            <a:off x="571500" y="2665214"/>
+            <a:ext cx="9934575" cy="885825"/>
           </a:xfrm>
           <a:prstGeom prst="rect">
             <a:avLst/>
@@ -5010,7 +5010,7 @@
         </p:nvSpPr>
         <p:spPr>
           <a:xfrm>
-            <a:off x="628650" y="3308152"/>
+            <a:off x="571500" y="3646289"/>
             <a:ext cx="7486650" cy="559891"/>
           </a:xfrm>
           <a:prstGeom prst="rect">
@@ -5052,8 +5052,8 @@
         </p:nvSpPr>
         <p:spPr>
           <a:xfrm>
-            <a:off x="628650" y="4191893"/>
-            <a:ext cx="9820275" cy="177165"/>
+            <a:off x="571500" y="4530030"/>
+            <a:ext cx="9934575" cy="177165"/>
           </a:xfrm>
           <a:prstGeom prst="rect">
             <a:avLst/>
@@ -5094,8 +5094,8 @@
         </p:nvSpPr>
         <p:spPr>
           <a:xfrm>
-            <a:off x="628650" y="4426148"/>
-            <a:ext cx="9820275" cy="177165"/>
+            <a:off x="571500" y="4764286"/>
+            <a:ext cx="9934575" cy="177165"/>
           </a:xfrm>
           <a:prstGeom prst="rect">
             <a:avLst/>
@@ -5130,62 +5130,23 @@
       </p:sp>
       <p:sp>
         <p:nvSpPr>
-          <p:cNvPr id="10" name="Text 8"/>
+          <p:cNvPr id="10" name="Shape 8"/>
           <p:cNvSpPr/>
           <p:nvPr/>
         </p:nvSpPr>
         <p:spPr>
           <a:xfrm>
-            <a:off x="628650" y="4993779"/>
-            <a:ext cx="8629650" cy="381000"/>
+            <a:off x="495300" y="7038975"/>
+            <a:ext cx="9705975" cy="9525"/>
           </a:xfrm>
           <a:prstGeom prst="rect">
             <a:avLst/>
           </a:prstGeom>
-          <a:noFill/>
+          <a:solidFill>
+            <a:srgbClr val="E3EBF6"/>
+          </a:solidFill>
           <a:ln/>
         </p:spPr>
-        <p:txBody>
-          <a:bodyPr wrap="square" lIns="0" tIns="0" rIns="0" bIns="0" rtlCol="0" anchor="t"/>
-          <a:lstStyle/>
-          <a:p>
-            <a:pPr algn="l" indent="0" marL="0">
-              <a:lnSpc>
-                <a:spcPts val="1500"/>
-              </a:lnSpc>
-              <a:buNone/>
-            </a:pPr>
-            <a:r>
-              <a:rPr lang="en-US" sz="950" b="1" dirty="0">
-                <a:solidFill>
-                  <a:srgbClr val="E7B860"/>
-                </a:solidFill>
-                <a:latin typeface="Lato" pitchFamily="34" charset="0"/>
-                <a:ea typeface="Lato" pitchFamily="34" charset="-122"/>
-                <a:cs typeface="Lato" pitchFamily="34" charset="-120"/>
-              </a:rPr>
-              <a:t>Elaborado por:</a:t>
-            </a:r>
-            <a:pPr algn="l" indent="0" marL="0">
-              <a:lnSpc>
-                <a:spcPts val="1500"/>
-              </a:lnSpc>
-              <a:buNone/>
-            </a:pPr>
-            <a:r>
-              <a:rPr lang="en-US" sz="950" dirty="0">
-                <a:solidFill>
-                  <a:srgbClr val="D8E3F2"/>
-                </a:solidFill>
-                <a:latin typeface="Lato" pitchFamily="34" charset="0"/>
-                <a:ea typeface="Lato" pitchFamily="34" charset="-122"/>
-                <a:cs typeface="Lato" pitchFamily="34" charset="-120"/>
-              </a:rPr>
-              <a:t> Emmanuel Miranda, Fabián R. Álvarez · Gustavo Maida, Marlene Figueroa, Benjamín Sacido, Hernán Corro, Alejandra Quintana, Verónica Orosco</a:t>
-            </a:r>
-            <a:endParaRPr lang="en-US" sz="950" dirty="0"/>
-          </a:p>
-        </p:txBody>
       </p:sp>
       <p:sp>
         <p:nvSpPr>
@@ -5195,8 +5156,8 @@
         </p:nvSpPr>
         <p:spPr>
           <a:xfrm>
-            <a:off x="628650" y="5374779"/>
-            <a:ext cx="8953500" cy="190500"/>
+            <a:off x="495300" y="7115175"/>
+            <a:ext cx="7639050" cy="157163"/>
           </a:xfrm>
           <a:prstGeom prst="rect">
             <a:avLst/>
@@ -5210,12 +5171,12 @@
           <a:p>
             <a:pPr algn="l" indent="0" marL="0">
               <a:lnSpc>
-                <a:spcPts val="1500"/>
+                <a:spcPts val="1238"/>
               </a:lnSpc>
               <a:buNone/>
             </a:pPr>
             <a:r>
-              <a:rPr lang="en-US" sz="950" b="1" dirty="0">
+              <a:rPr lang="en-US" sz="850" b="1" dirty="0">
                 <a:solidFill>
                   <a:srgbClr val="E7B860"/>
                 </a:solidFill>
@@ -5223,16 +5184,16 @@
                 <a:ea typeface="Lato" pitchFamily="34" charset="-122"/>
                 <a:cs typeface="Lato" pitchFamily="34" charset="-120"/>
               </a:rPr>
-              <a:t>Dudas/consultas:</a:t>
+              <a:t>Elaborado por:</a:t>
             </a:r>
             <a:pPr algn="l" indent="0" marL="0">
               <a:lnSpc>
-                <a:spcPts val="1500"/>
+                <a:spcPts val="1238"/>
               </a:lnSpc>
               <a:buNone/>
             </a:pPr>
             <a:r>
-              <a:rPr lang="en-US" sz="950" dirty="0">
+              <a:rPr lang="en-US" sz="850" dirty="0">
                 <a:solidFill>
                   <a:srgbClr val="D8E3F2"/>
                 </a:solidFill>
@@ -5240,9 +5201,9 @@
                 <a:ea typeface="Lato" pitchFamily="34" charset="-122"/>
                 <a:cs typeface="Lato" pitchFamily="34" charset="-120"/>
               </a:rPr>
-              <a:t> emmanuel.miranda@trenesargentinos.gob.ar · fabian.alvarez@trenesargentinos.gob.ar</a:t>
+              <a:t> Emmanuel Miranda, Fabián R. Álvarez · Gustavo Maida, Marlene Figueroa, Benjamín Sacido, Hernán Corro, Alejandra Quintana, Verónica Orosco</a:t>
             </a:r>
-            <a:endParaRPr lang="en-US" sz="950" dirty="0"/>
+            <a:endParaRPr lang="en-US" sz="850" dirty="0"/>
           </a:p>
         </p:txBody>
       </p:sp>
@@ -5254,8 +5215,8 @@
         </p:nvSpPr>
         <p:spPr>
           <a:xfrm>
-            <a:off x="438150" y="7267129"/>
-            <a:ext cx="8458200" cy="162401"/>
+            <a:off x="495300" y="7272338"/>
+            <a:ext cx="7639050" cy="157163"/>
           </a:xfrm>
           <a:prstGeom prst="rect">
             <a:avLst/>
@@ -5269,20 +5230,37 @@
           <a:p>
             <a:pPr algn="l" indent="0" marL="0">
               <a:lnSpc>
-                <a:spcPts val="1279"/>
+                <a:spcPts val="1238"/>
+              </a:lnSpc>
+              <a:buNone/>
+            </a:pPr>
+            <a:r>
+              <a:rPr lang="en-US" sz="850" b="1" dirty="0">
+                <a:solidFill>
+                  <a:srgbClr val="E7B860"/>
+                </a:solidFill>
+                <a:latin typeface="Lato" pitchFamily="34" charset="0"/>
+                <a:ea typeface="Lato" pitchFamily="34" charset="-122"/>
+                <a:cs typeface="Lato" pitchFamily="34" charset="-120"/>
+              </a:rPr>
+              <a:t>Dudas/consultas:</a:t>
+            </a:r>
+            <a:pPr algn="l" indent="0" marL="0">
+              <a:lnSpc>
+                <a:spcPts val="1238"/>
               </a:lnSpc>
               <a:buNone/>
             </a:pPr>
             <a:r>
               <a:rPr lang="en-US" sz="850" dirty="0">
                 <a:solidFill>
-                  <a:srgbClr val="AEC6E4"/>
+                  <a:srgbClr val="D8E3F2"/>
                 </a:solidFill>
                 <a:latin typeface="Lato" pitchFamily="34" charset="0"/>
                 <a:ea typeface="Lato" pitchFamily="34" charset="-122"/>
                 <a:cs typeface="Lato" pitchFamily="34" charset="-120"/>
               </a:rPr>
-              <a:t>SOFSA · Presupuesto 2027 · Subgerencia de Presupuesto y Control de Gestión · consultas: emmanuel.miranda@trenesargentinos.gob.ar · fabian.alvarez@trenesargentinos.gob.ar</a:t>
+              <a:t> emmanuel.miranda@trenesargentinos.gob.ar · fabian.alvarez@trenesargentinos.gob.ar</a:t>
             </a:r>
             <a:endParaRPr lang="en-US" sz="850" dirty="0"/>
           </a:p>
@@ -5296,8 +5274,8 @@
         </p:nvSpPr>
         <p:spPr>
           <a:xfrm>
-            <a:off x="10010775" y="7267129"/>
-            <a:ext cx="628650" cy="162401"/>
+            <a:off x="8286750" y="7272338"/>
+            <a:ext cx="1914525" cy="157163"/>
           </a:xfrm>
           <a:prstGeom prst="rect">
             <a:avLst/>
@@ -5309,9 +5287,9 @@
           <a:bodyPr wrap="none" lIns="0" tIns="0" rIns="0" bIns="0" rtlCol="0" anchor="t"/>
           <a:lstStyle/>
           <a:p>
-            <a:pPr algn="l" indent="0" marL="0">
+            <a:pPr algn="r" indent="0" marL="0">
               <a:lnSpc>
-                <a:spcPts val="1279"/>
+                <a:spcPts val="1238"/>
               </a:lnSpc>
               <a:buNone/>
             </a:pPr>
@@ -5324,7 +5302,7 @@
                 <a:ea typeface="Lato" pitchFamily="34" charset="-122"/>
                 <a:cs typeface="Lato" pitchFamily="34" charset="-120"/>
               </a:rPr>
-              <a:t>1 / 17</a:t>
+              <a:t>SOFSA · Presupuesto 2027 · 1 / 17</a:t>
             </a:r>
             <a:endParaRPr lang="en-US" sz="850" dirty="0"/>
           </a:p>
@@ -8074,14 +8052,34 @@
       </p:sp>
       <p:sp>
         <p:nvSpPr>
-          <p:cNvPr id="10" name="Text 6"/>
+          <p:cNvPr id="10" name="Shape 6"/>
           <p:cNvSpPr/>
           <p:nvPr/>
         </p:nvSpPr>
         <p:spPr>
           <a:xfrm>
-            <a:off x="438150" y="7267129"/>
-            <a:ext cx="8458200" cy="162401"/>
+            <a:off x="495300" y="7038975"/>
+            <a:ext cx="9705975" cy="9525"/>
+          </a:xfrm>
+          <a:prstGeom prst="rect">
+            <a:avLst/>
+          </a:prstGeom>
+          <a:solidFill>
+            <a:srgbClr val="E5E8F0"/>
+          </a:solidFill>
+          <a:ln/>
+        </p:spPr>
+      </p:sp>
+      <p:sp>
+        <p:nvSpPr>
+          <p:cNvPr id="11" name="Text 7"/>
+          <p:cNvSpPr/>
+          <p:nvPr/>
+        </p:nvSpPr>
+        <p:spPr>
+          <a:xfrm>
+            <a:off x="495300" y="7115175"/>
+            <a:ext cx="7639050" cy="157163"/>
           </a:xfrm>
           <a:prstGeom prst="rect">
             <a:avLst/>
@@ -8095,20 +8093,37 @@
           <a:p>
             <a:pPr algn="l" indent="0" marL="0">
               <a:lnSpc>
-                <a:spcPts val="1279"/>
+                <a:spcPts val="1238"/>
+              </a:lnSpc>
+              <a:buNone/>
+            </a:pPr>
+            <a:r>
+              <a:rPr lang="en-US" sz="850" b="1" dirty="0">
+                <a:solidFill>
+                  <a:srgbClr val="222C4F"/>
+                </a:solidFill>
+                <a:latin typeface="Lato" pitchFamily="34" charset="0"/>
+                <a:ea typeface="Lato" pitchFamily="34" charset="-122"/>
+                <a:cs typeface="Lato" pitchFamily="34" charset="-120"/>
+              </a:rPr>
+              <a:t>Elaborado por:</a:t>
+            </a:r>
+            <a:pPr algn="l" indent="0" marL="0">
+              <a:lnSpc>
+                <a:spcPts val="1238"/>
               </a:lnSpc>
               <a:buNone/>
             </a:pPr>
             <a:r>
               <a:rPr lang="en-US" sz="850" dirty="0">
                 <a:solidFill>
-                  <a:srgbClr val="5C6073"/>
+                  <a:srgbClr val="5A6072"/>
                 </a:solidFill>
                 <a:latin typeface="Lato" pitchFamily="34" charset="0"/>
                 <a:ea typeface="Lato" pitchFamily="34" charset="-122"/>
                 <a:cs typeface="Lato" pitchFamily="34" charset="-120"/>
               </a:rPr>
-              <a:t>SOFSA · Presupuesto 2027 · Subgerencia de Presupuesto y Control de Gestión · consultas: emmanuel.miranda@trenesargentinos.gob.ar · fabian.alvarez@trenesargentinos.gob.ar</a:t>
+              <a:t> Emmanuel Miranda, Fabián R. Álvarez · Gustavo Maida, Marlene Figueroa, Benjamín Sacido, Hernán Corro, Alejandra Quintana, Verónica Orosco</a:t>
             </a:r>
             <a:endParaRPr lang="en-US" sz="850" dirty="0"/>
           </a:p>
@@ -8116,14 +8131,14 @@
       </p:sp>
       <p:sp>
         <p:nvSpPr>
-          <p:cNvPr id="11" name="Text 7"/>
+          <p:cNvPr id="12" name="Text 8"/>
           <p:cNvSpPr/>
           <p:nvPr/>
         </p:nvSpPr>
         <p:spPr>
           <a:xfrm>
-            <a:off x="9953625" y="7267129"/>
-            <a:ext cx="685800" cy="162401"/>
+            <a:off x="495300" y="7272338"/>
+            <a:ext cx="7639050" cy="157163"/>
           </a:xfrm>
           <a:prstGeom prst="rect">
             <a:avLst/>
@@ -8137,7 +8152,66 @@
           <a:p>
             <a:pPr algn="l" indent="0" marL="0">
               <a:lnSpc>
-                <a:spcPts val="1279"/>
+                <a:spcPts val="1238"/>
+              </a:lnSpc>
+              <a:buNone/>
+            </a:pPr>
+            <a:r>
+              <a:rPr lang="en-US" sz="850" b="1" dirty="0">
+                <a:solidFill>
+                  <a:srgbClr val="222C4F"/>
+                </a:solidFill>
+                <a:latin typeface="Lato" pitchFamily="34" charset="0"/>
+                <a:ea typeface="Lato" pitchFamily="34" charset="-122"/>
+                <a:cs typeface="Lato" pitchFamily="34" charset="-120"/>
+              </a:rPr>
+              <a:t>Dudas/consultas:</a:t>
+            </a:r>
+            <a:pPr algn="l" indent="0" marL="0">
+              <a:lnSpc>
+                <a:spcPts val="1238"/>
+              </a:lnSpc>
+              <a:buNone/>
+            </a:pPr>
+            <a:r>
+              <a:rPr lang="en-US" sz="850" dirty="0">
+                <a:solidFill>
+                  <a:srgbClr val="5A6072"/>
+                </a:solidFill>
+                <a:latin typeface="Lato" pitchFamily="34" charset="0"/>
+                <a:ea typeface="Lato" pitchFamily="34" charset="-122"/>
+                <a:cs typeface="Lato" pitchFamily="34" charset="-120"/>
+              </a:rPr>
+              <a:t> emmanuel.miranda@trenesargentinos.gob.ar · fabian.alvarez@trenesargentinos.gob.ar</a:t>
+            </a:r>
+            <a:endParaRPr lang="en-US" sz="850" dirty="0"/>
+          </a:p>
+        </p:txBody>
+      </p:sp>
+      <p:sp>
+        <p:nvSpPr>
+          <p:cNvPr id="13" name="Text 9"/>
+          <p:cNvSpPr/>
+          <p:nvPr/>
+        </p:nvSpPr>
+        <p:spPr>
+          <a:xfrm>
+            <a:off x="8229600" y="7272338"/>
+            <a:ext cx="1971675" cy="157163"/>
+          </a:xfrm>
+          <a:prstGeom prst="rect">
+            <a:avLst/>
+          </a:prstGeom>
+          <a:noFill/>
+          <a:ln/>
+        </p:spPr>
+        <p:txBody>
+          <a:bodyPr wrap="none" lIns="0" tIns="0" rIns="0" bIns="0" rtlCol="0" anchor="t"/>
+          <a:lstStyle/>
+          <a:p>
+            <a:pPr algn="r" indent="0" marL="0">
+              <a:lnSpc>
+                <a:spcPts val="1238"/>
               </a:lnSpc>
               <a:buNone/>
             </a:pPr>
@@ -8150,7 +8224,7 @@
                 <a:ea typeface="Lato" pitchFamily="34" charset="-122"/>
                 <a:cs typeface="Lato" pitchFamily="34" charset="-120"/>
               </a:rPr>
-              <a:t>10 / 17</a:t>
+              <a:t>SOFSA · Presupuesto 2027 · 10 / 17</a:t>
             </a:r>
             <a:endParaRPr lang="en-US" sz="850" dirty="0"/>
           </a:p>
@@ -8330,14 +8404,34 @@
       </p:sp>
       <p:sp>
         <p:nvSpPr>
-          <p:cNvPr id="7" name="Text 4"/>
+          <p:cNvPr id="7" name="Shape 4"/>
           <p:cNvSpPr/>
           <p:nvPr/>
         </p:nvSpPr>
         <p:spPr>
           <a:xfrm>
-            <a:off x="438150" y="7267129"/>
-            <a:ext cx="8458200" cy="162401"/>
+            <a:off x="495300" y="7038975"/>
+            <a:ext cx="9705975" cy="9525"/>
+          </a:xfrm>
+          <a:prstGeom prst="rect">
+            <a:avLst/>
+          </a:prstGeom>
+          <a:solidFill>
+            <a:srgbClr val="E5E8F0"/>
+          </a:solidFill>
+          <a:ln/>
+        </p:spPr>
+      </p:sp>
+      <p:sp>
+        <p:nvSpPr>
+          <p:cNvPr id="8" name="Text 5"/>
+          <p:cNvSpPr/>
+          <p:nvPr/>
+        </p:nvSpPr>
+        <p:spPr>
+          <a:xfrm>
+            <a:off x="495300" y="7115175"/>
+            <a:ext cx="7639050" cy="157163"/>
           </a:xfrm>
           <a:prstGeom prst="rect">
             <a:avLst/>
@@ -8351,20 +8445,37 @@
           <a:p>
             <a:pPr algn="l" indent="0" marL="0">
               <a:lnSpc>
-                <a:spcPts val="1279"/>
+                <a:spcPts val="1238"/>
+              </a:lnSpc>
+              <a:buNone/>
+            </a:pPr>
+            <a:r>
+              <a:rPr lang="en-US" sz="850" b="1" dirty="0">
+                <a:solidFill>
+                  <a:srgbClr val="222C4F"/>
+                </a:solidFill>
+                <a:latin typeface="Lato" pitchFamily="34" charset="0"/>
+                <a:ea typeface="Lato" pitchFamily="34" charset="-122"/>
+                <a:cs typeface="Lato" pitchFamily="34" charset="-120"/>
+              </a:rPr>
+              <a:t>Elaborado por:</a:t>
+            </a:r>
+            <a:pPr algn="l" indent="0" marL="0">
+              <a:lnSpc>
+                <a:spcPts val="1238"/>
               </a:lnSpc>
               <a:buNone/>
             </a:pPr>
             <a:r>
               <a:rPr lang="en-US" sz="850" dirty="0">
                 <a:solidFill>
-                  <a:srgbClr val="5C6073"/>
+                  <a:srgbClr val="5A6072"/>
                 </a:solidFill>
                 <a:latin typeface="Lato" pitchFamily="34" charset="0"/>
                 <a:ea typeface="Lato" pitchFamily="34" charset="-122"/>
                 <a:cs typeface="Lato" pitchFamily="34" charset="-120"/>
               </a:rPr>
-              <a:t>SOFSA · Presupuesto 2027 · Subgerencia de Presupuesto y Control de Gestión · consultas: emmanuel.miranda@trenesargentinos.gob.ar · fabian.alvarez@trenesargentinos.gob.ar</a:t>
+              <a:t> Emmanuel Miranda, Fabián R. Álvarez · Gustavo Maida, Marlene Figueroa, Benjamín Sacido, Hernán Corro, Alejandra Quintana, Verónica Orosco</a:t>
             </a:r>
             <a:endParaRPr lang="en-US" sz="850" dirty="0"/>
           </a:p>
@@ -8372,14 +8483,14 @@
       </p:sp>
       <p:sp>
         <p:nvSpPr>
-          <p:cNvPr id="8" name="Text 5"/>
+          <p:cNvPr id="9" name="Text 6"/>
           <p:cNvSpPr/>
           <p:nvPr/>
         </p:nvSpPr>
         <p:spPr>
           <a:xfrm>
-            <a:off x="9953625" y="7267129"/>
-            <a:ext cx="685800" cy="162401"/>
+            <a:off x="495300" y="7272338"/>
+            <a:ext cx="7639050" cy="157163"/>
           </a:xfrm>
           <a:prstGeom prst="rect">
             <a:avLst/>
@@ -8393,7 +8504,66 @@
           <a:p>
             <a:pPr algn="l" indent="0" marL="0">
               <a:lnSpc>
-                <a:spcPts val="1279"/>
+                <a:spcPts val="1238"/>
+              </a:lnSpc>
+              <a:buNone/>
+            </a:pPr>
+            <a:r>
+              <a:rPr lang="en-US" sz="850" b="1" dirty="0">
+                <a:solidFill>
+                  <a:srgbClr val="222C4F"/>
+                </a:solidFill>
+                <a:latin typeface="Lato" pitchFamily="34" charset="0"/>
+                <a:ea typeface="Lato" pitchFamily="34" charset="-122"/>
+                <a:cs typeface="Lato" pitchFamily="34" charset="-120"/>
+              </a:rPr>
+              <a:t>Dudas/consultas:</a:t>
+            </a:r>
+            <a:pPr algn="l" indent="0" marL="0">
+              <a:lnSpc>
+                <a:spcPts val="1238"/>
+              </a:lnSpc>
+              <a:buNone/>
+            </a:pPr>
+            <a:r>
+              <a:rPr lang="en-US" sz="850" dirty="0">
+                <a:solidFill>
+                  <a:srgbClr val="5A6072"/>
+                </a:solidFill>
+                <a:latin typeface="Lato" pitchFamily="34" charset="0"/>
+                <a:ea typeface="Lato" pitchFamily="34" charset="-122"/>
+                <a:cs typeface="Lato" pitchFamily="34" charset="-120"/>
+              </a:rPr>
+              <a:t> emmanuel.miranda@trenesargentinos.gob.ar · fabian.alvarez@trenesargentinos.gob.ar</a:t>
+            </a:r>
+            <a:endParaRPr lang="en-US" sz="850" dirty="0"/>
+          </a:p>
+        </p:txBody>
+      </p:sp>
+      <p:sp>
+        <p:nvSpPr>
+          <p:cNvPr id="10" name="Text 7"/>
+          <p:cNvSpPr/>
+          <p:nvPr/>
+        </p:nvSpPr>
+        <p:spPr>
+          <a:xfrm>
+            <a:off x="8229600" y="7272338"/>
+            <a:ext cx="1971675" cy="157163"/>
+          </a:xfrm>
+          <a:prstGeom prst="rect">
+            <a:avLst/>
+          </a:prstGeom>
+          <a:noFill/>
+          <a:ln/>
+        </p:spPr>
+        <p:txBody>
+          <a:bodyPr wrap="none" lIns="0" tIns="0" rIns="0" bIns="0" rtlCol="0" anchor="t"/>
+          <a:lstStyle/>
+          <a:p>
+            <a:pPr algn="r" indent="0" marL="0">
+              <a:lnSpc>
+                <a:spcPts val="1238"/>
               </a:lnSpc>
               <a:buNone/>
             </a:pPr>
@@ -8406,7 +8576,7 @@
                 <a:ea typeface="Lato" pitchFamily="34" charset="-122"/>
                 <a:cs typeface="Lato" pitchFamily="34" charset="-120"/>
               </a:rPr>
-              <a:t>11 / 17</a:t>
+              <a:t>SOFSA · Presupuesto 2027 · 11 / 17</a:t>
             </a:r>
             <a:endParaRPr lang="en-US" sz="850" dirty="0"/>
           </a:p>
@@ -9570,14 +9740,34 @@
       </p:sp>
       <p:sp>
         <p:nvSpPr>
-          <p:cNvPr id="34" name="Text 32"/>
+          <p:cNvPr id="34" name="Shape 32"/>
           <p:cNvSpPr/>
           <p:nvPr/>
         </p:nvSpPr>
         <p:spPr>
           <a:xfrm>
-            <a:off x="438150" y="7267129"/>
-            <a:ext cx="8458200" cy="162401"/>
+            <a:off x="495300" y="7038975"/>
+            <a:ext cx="9705975" cy="9525"/>
+          </a:xfrm>
+          <a:prstGeom prst="rect">
+            <a:avLst/>
+          </a:prstGeom>
+          <a:solidFill>
+            <a:srgbClr val="E5E8F0"/>
+          </a:solidFill>
+          <a:ln/>
+        </p:spPr>
+      </p:sp>
+      <p:sp>
+        <p:nvSpPr>
+          <p:cNvPr id="35" name="Text 33"/>
+          <p:cNvSpPr/>
+          <p:nvPr/>
+        </p:nvSpPr>
+        <p:spPr>
+          <a:xfrm>
+            <a:off x="495300" y="7115175"/>
+            <a:ext cx="7639050" cy="157163"/>
           </a:xfrm>
           <a:prstGeom prst="rect">
             <a:avLst/>
@@ -9591,20 +9781,37 @@
           <a:p>
             <a:pPr algn="l" indent="0" marL="0">
               <a:lnSpc>
-                <a:spcPts val="1279"/>
+                <a:spcPts val="1238"/>
+              </a:lnSpc>
+              <a:buNone/>
+            </a:pPr>
+            <a:r>
+              <a:rPr lang="en-US" sz="850" b="1" dirty="0">
+                <a:solidFill>
+                  <a:srgbClr val="222C4F"/>
+                </a:solidFill>
+                <a:latin typeface="Lato" pitchFamily="34" charset="0"/>
+                <a:ea typeface="Lato" pitchFamily="34" charset="-122"/>
+                <a:cs typeface="Lato" pitchFamily="34" charset="-120"/>
+              </a:rPr>
+              <a:t>Elaborado por:</a:t>
+            </a:r>
+            <a:pPr algn="l" indent="0" marL="0">
+              <a:lnSpc>
+                <a:spcPts val="1238"/>
               </a:lnSpc>
               <a:buNone/>
             </a:pPr>
             <a:r>
               <a:rPr lang="en-US" sz="850" dirty="0">
                 <a:solidFill>
-                  <a:srgbClr val="5C6073"/>
+                  <a:srgbClr val="5A6072"/>
                 </a:solidFill>
                 <a:latin typeface="Lato" pitchFamily="34" charset="0"/>
                 <a:ea typeface="Lato" pitchFamily="34" charset="-122"/>
                 <a:cs typeface="Lato" pitchFamily="34" charset="-120"/>
               </a:rPr>
-              <a:t>SOFSA · Presupuesto 2027 · Subgerencia de Presupuesto y Control de Gestión · consultas: emmanuel.miranda@trenesargentinos.gob.ar · fabian.alvarez@trenesargentinos.gob.ar</a:t>
+              <a:t> Emmanuel Miranda, Fabián R. Álvarez · Gustavo Maida, Marlene Figueroa, Benjamín Sacido, Hernán Corro, Alejandra Quintana, Verónica Orosco</a:t>
             </a:r>
             <a:endParaRPr lang="en-US" sz="850" dirty="0"/>
           </a:p>
@@ -9612,14 +9819,14 @@
       </p:sp>
       <p:sp>
         <p:nvSpPr>
-          <p:cNvPr id="35" name="Text 33"/>
+          <p:cNvPr id="36" name="Text 34"/>
           <p:cNvSpPr/>
           <p:nvPr/>
         </p:nvSpPr>
         <p:spPr>
           <a:xfrm>
-            <a:off x="9953625" y="7267129"/>
-            <a:ext cx="685800" cy="162401"/>
+            <a:off x="495300" y="7272338"/>
+            <a:ext cx="7639050" cy="157163"/>
           </a:xfrm>
           <a:prstGeom prst="rect">
             <a:avLst/>
@@ -9633,7 +9840,66 @@
           <a:p>
             <a:pPr algn="l" indent="0" marL="0">
               <a:lnSpc>
-                <a:spcPts val="1279"/>
+                <a:spcPts val="1238"/>
+              </a:lnSpc>
+              <a:buNone/>
+            </a:pPr>
+            <a:r>
+              <a:rPr lang="en-US" sz="850" b="1" dirty="0">
+                <a:solidFill>
+                  <a:srgbClr val="222C4F"/>
+                </a:solidFill>
+                <a:latin typeface="Lato" pitchFamily="34" charset="0"/>
+                <a:ea typeface="Lato" pitchFamily="34" charset="-122"/>
+                <a:cs typeface="Lato" pitchFamily="34" charset="-120"/>
+              </a:rPr>
+              <a:t>Dudas/consultas:</a:t>
+            </a:r>
+            <a:pPr algn="l" indent="0" marL="0">
+              <a:lnSpc>
+                <a:spcPts val="1238"/>
+              </a:lnSpc>
+              <a:buNone/>
+            </a:pPr>
+            <a:r>
+              <a:rPr lang="en-US" sz="850" dirty="0">
+                <a:solidFill>
+                  <a:srgbClr val="5A6072"/>
+                </a:solidFill>
+                <a:latin typeface="Lato" pitchFamily="34" charset="0"/>
+                <a:ea typeface="Lato" pitchFamily="34" charset="-122"/>
+                <a:cs typeface="Lato" pitchFamily="34" charset="-120"/>
+              </a:rPr>
+              <a:t> emmanuel.miranda@trenesargentinos.gob.ar · fabian.alvarez@trenesargentinos.gob.ar</a:t>
+            </a:r>
+            <a:endParaRPr lang="en-US" sz="850" dirty="0"/>
+          </a:p>
+        </p:txBody>
+      </p:sp>
+      <p:sp>
+        <p:nvSpPr>
+          <p:cNvPr id="37" name="Text 35"/>
+          <p:cNvSpPr/>
+          <p:nvPr/>
+        </p:nvSpPr>
+        <p:spPr>
+          <a:xfrm>
+            <a:off x="8229600" y="7272338"/>
+            <a:ext cx="1971675" cy="157163"/>
+          </a:xfrm>
+          <a:prstGeom prst="rect">
+            <a:avLst/>
+          </a:prstGeom>
+          <a:noFill/>
+          <a:ln/>
+        </p:spPr>
+        <p:txBody>
+          <a:bodyPr wrap="none" lIns="0" tIns="0" rIns="0" bIns="0" rtlCol="0" anchor="t"/>
+          <a:lstStyle/>
+          <a:p>
+            <a:pPr algn="r" indent="0" marL="0">
+              <a:lnSpc>
+                <a:spcPts val="1238"/>
               </a:lnSpc>
               <a:buNone/>
             </a:pPr>
@@ -9646,7 +9912,7 @@
                 <a:ea typeface="Lato" pitchFamily="34" charset="-122"/>
                 <a:cs typeface="Lato" pitchFamily="34" charset="-120"/>
               </a:rPr>
-              <a:t>12 / 17</a:t>
+              <a:t>SOFSA · Presupuesto 2027 · 12 / 17</a:t>
             </a:r>
             <a:endParaRPr lang="en-US" sz="850" dirty="0"/>
           </a:p>
@@ -11664,14 +11930,34 @@
       </p:graphicFrame>
       <p:sp>
         <p:nvSpPr>
-          <p:cNvPr id="7" name="Text 4"/>
+          <p:cNvPr id="7" name="Shape 4"/>
           <p:cNvSpPr/>
           <p:nvPr/>
         </p:nvSpPr>
         <p:spPr>
           <a:xfrm>
-            <a:off x="438150" y="7267129"/>
-            <a:ext cx="8458200" cy="162401"/>
+            <a:off x="495300" y="7038975"/>
+            <a:ext cx="9705975" cy="9525"/>
+          </a:xfrm>
+          <a:prstGeom prst="rect">
+            <a:avLst/>
+          </a:prstGeom>
+          <a:solidFill>
+            <a:srgbClr val="E5E8F0"/>
+          </a:solidFill>
+          <a:ln/>
+        </p:spPr>
+      </p:sp>
+      <p:sp>
+        <p:nvSpPr>
+          <p:cNvPr id="8" name="Text 5"/>
+          <p:cNvSpPr/>
+          <p:nvPr/>
+        </p:nvSpPr>
+        <p:spPr>
+          <a:xfrm>
+            <a:off x="495300" y="7115175"/>
+            <a:ext cx="7639050" cy="157163"/>
           </a:xfrm>
           <a:prstGeom prst="rect">
             <a:avLst/>
@@ -11685,20 +11971,37 @@
           <a:p>
             <a:pPr algn="l" indent="0" marL="0">
               <a:lnSpc>
-                <a:spcPts val="1279"/>
+                <a:spcPts val="1238"/>
+              </a:lnSpc>
+              <a:buNone/>
+            </a:pPr>
+            <a:r>
+              <a:rPr lang="en-US" sz="850" b="1" dirty="0">
+                <a:solidFill>
+                  <a:srgbClr val="222C4F"/>
+                </a:solidFill>
+                <a:latin typeface="Lato" pitchFamily="34" charset="0"/>
+                <a:ea typeface="Lato" pitchFamily="34" charset="-122"/>
+                <a:cs typeface="Lato" pitchFamily="34" charset="-120"/>
+              </a:rPr>
+              <a:t>Elaborado por:</a:t>
+            </a:r>
+            <a:pPr algn="l" indent="0" marL="0">
+              <a:lnSpc>
+                <a:spcPts val="1238"/>
               </a:lnSpc>
               <a:buNone/>
             </a:pPr>
             <a:r>
               <a:rPr lang="en-US" sz="850" dirty="0">
                 <a:solidFill>
-                  <a:srgbClr val="5C6073"/>
+                  <a:srgbClr val="5A6072"/>
                 </a:solidFill>
                 <a:latin typeface="Lato" pitchFamily="34" charset="0"/>
                 <a:ea typeface="Lato" pitchFamily="34" charset="-122"/>
                 <a:cs typeface="Lato" pitchFamily="34" charset="-120"/>
               </a:rPr>
-              <a:t>SOFSA · Presupuesto 2027 · Subgerencia de Presupuesto y Control de Gestión · consultas: emmanuel.miranda@trenesargentinos.gob.ar · fabian.alvarez@trenesargentinos.gob.ar</a:t>
+              <a:t> Emmanuel Miranda, Fabián R. Álvarez · Gustavo Maida, Marlene Figueroa, Benjamín Sacido, Hernán Corro, Alejandra Quintana, Verónica Orosco</a:t>
             </a:r>
             <a:endParaRPr lang="en-US" sz="850" dirty="0"/>
           </a:p>
@@ -11706,14 +12009,14 @@
       </p:sp>
       <p:sp>
         <p:nvSpPr>
-          <p:cNvPr id="8" name="Text 5"/>
+          <p:cNvPr id="9" name="Text 6"/>
           <p:cNvSpPr/>
           <p:nvPr/>
         </p:nvSpPr>
         <p:spPr>
           <a:xfrm>
-            <a:off x="9953625" y="7267129"/>
-            <a:ext cx="685800" cy="162401"/>
+            <a:off x="495300" y="7272338"/>
+            <a:ext cx="7639050" cy="157163"/>
           </a:xfrm>
           <a:prstGeom prst="rect">
             <a:avLst/>
@@ -11727,7 +12030,66 @@
           <a:p>
             <a:pPr algn="l" indent="0" marL="0">
               <a:lnSpc>
-                <a:spcPts val="1279"/>
+                <a:spcPts val="1238"/>
+              </a:lnSpc>
+              <a:buNone/>
+            </a:pPr>
+            <a:r>
+              <a:rPr lang="en-US" sz="850" b="1" dirty="0">
+                <a:solidFill>
+                  <a:srgbClr val="222C4F"/>
+                </a:solidFill>
+                <a:latin typeface="Lato" pitchFamily="34" charset="0"/>
+                <a:ea typeface="Lato" pitchFamily="34" charset="-122"/>
+                <a:cs typeface="Lato" pitchFamily="34" charset="-120"/>
+              </a:rPr>
+              <a:t>Dudas/consultas:</a:t>
+            </a:r>
+            <a:pPr algn="l" indent="0" marL="0">
+              <a:lnSpc>
+                <a:spcPts val="1238"/>
+              </a:lnSpc>
+              <a:buNone/>
+            </a:pPr>
+            <a:r>
+              <a:rPr lang="en-US" sz="850" dirty="0">
+                <a:solidFill>
+                  <a:srgbClr val="5A6072"/>
+                </a:solidFill>
+                <a:latin typeface="Lato" pitchFamily="34" charset="0"/>
+                <a:ea typeface="Lato" pitchFamily="34" charset="-122"/>
+                <a:cs typeface="Lato" pitchFamily="34" charset="-120"/>
+              </a:rPr>
+              <a:t> emmanuel.miranda@trenesargentinos.gob.ar · fabian.alvarez@trenesargentinos.gob.ar</a:t>
+            </a:r>
+            <a:endParaRPr lang="en-US" sz="850" dirty="0"/>
+          </a:p>
+        </p:txBody>
+      </p:sp>
+      <p:sp>
+        <p:nvSpPr>
+          <p:cNvPr id="10" name="Text 7"/>
+          <p:cNvSpPr/>
+          <p:nvPr/>
+        </p:nvSpPr>
+        <p:spPr>
+          <a:xfrm>
+            <a:off x="8229600" y="7272338"/>
+            <a:ext cx="1971675" cy="157163"/>
+          </a:xfrm>
+          <a:prstGeom prst="rect">
+            <a:avLst/>
+          </a:prstGeom>
+          <a:noFill/>
+          <a:ln/>
+        </p:spPr>
+        <p:txBody>
+          <a:bodyPr wrap="none" lIns="0" tIns="0" rIns="0" bIns="0" rtlCol="0" anchor="t"/>
+          <a:lstStyle/>
+          <a:p>
+            <a:pPr algn="r" indent="0" marL="0">
+              <a:lnSpc>
+                <a:spcPts val="1238"/>
               </a:lnSpc>
               <a:buNone/>
             </a:pPr>
@@ -11740,7 +12102,7 @@
                 <a:ea typeface="Lato" pitchFamily="34" charset="-122"/>
                 <a:cs typeface="Lato" pitchFamily="34" charset="-120"/>
               </a:rPr>
-              <a:t>13 / 17</a:t>
+              <a:t>SOFSA · Presupuesto 2027 · 13 / 17</a:t>
             </a:r>
             <a:endParaRPr lang="en-US" sz="850" dirty="0"/>
           </a:p>
@@ -13730,14 +14092,34 @@
       </p:graphicFrame>
       <p:sp>
         <p:nvSpPr>
-          <p:cNvPr id="7" name="Text 4"/>
+          <p:cNvPr id="7" name="Shape 4"/>
           <p:cNvSpPr/>
           <p:nvPr/>
         </p:nvSpPr>
         <p:spPr>
           <a:xfrm>
-            <a:off x="438150" y="7267129"/>
-            <a:ext cx="8458200" cy="162401"/>
+            <a:off x="495300" y="7038975"/>
+            <a:ext cx="9705975" cy="9525"/>
+          </a:xfrm>
+          <a:prstGeom prst="rect">
+            <a:avLst/>
+          </a:prstGeom>
+          <a:solidFill>
+            <a:srgbClr val="E5E8F0"/>
+          </a:solidFill>
+          <a:ln/>
+        </p:spPr>
+      </p:sp>
+      <p:sp>
+        <p:nvSpPr>
+          <p:cNvPr id="8" name="Text 5"/>
+          <p:cNvSpPr/>
+          <p:nvPr/>
+        </p:nvSpPr>
+        <p:spPr>
+          <a:xfrm>
+            <a:off x="495300" y="7115175"/>
+            <a:ext cx="7639050" cy="157163"/>
           </a:xfrm>
           <a:prstGeom prst="rect">
             <a:avLst/>
@@ -13751,20 +14133,37 @@
           <a:p>
             <a:pPr algn="l" indent="0" marL="0">
               <a:lnSpc>
-                <a:spcPts val="1279"/>
+                <a:spcPts val="1238"/>
+              </a:lnSpc>
+              <a:buNone/>
+            </a:pPr>
+            <a:r>
+              <a:rPr lang="en-US" sz="850" b="1" dirty="0">
+                <a:solidFill>
+                  <a:srgbClr val="222C4F"/>
+                </a:solidFill>
+                <a:latin typeface="Lato" pitchFamily="34" charset="0"/>
+                <a:ea typeface="Lato" pitchFamily="34" charset="-122"/>
+                <a:cs typeface="Lato" pitchFamily="34" charset="-120"/>
+              </a:rPr>
+              <a:t>Elaborado por:</a:t>
+            </a:r>
+            <a:pPr algn="l" indent="0" marL="0">
+              <a:lnSpc>
+                <a:spcPts val="1238"/>
               </a:lnSpc>
               <a:buNone/>
             </a:pPr>
             <a:r>
               <a:rPr lang="en-US" sz="850" dirty="0">
                 <a:solidFill>
-                  <a:srgbClr val="5C6073"/>
+                  <a:srgbClr val="5A6072"/>
                 </a:solidFill>
                 <a:latin typeface="Lato" pitchFamily="34" charset="0"/>
                 <a:ea typeface="Lato" pitchFamily="34" charset="-122"/>
                 <a:cs typeface="Lato" pitchFamily="34" charset="-120"/>
               </a:rPr>
-              <a:t>SOFSA · Presupuesto 2027 · Subgerencia de Presupuesto y Control de Gestión · consultas: emmanuel.miranda@trenesargentinos.gob.ar · fabian.alvarez@trenesargentinos.gob.ar</a:t>
+              <a:t> Emmanuel Miranda, Fabián R. Álvarez · Gustavo Maida, Marlene Figueroa, Benjamín Sacido, Hernán Corro, Alejandra Quintana, Verónica Orosco</a:t>
             </a:r>
             <a:endParaRPr lang="en-US" sz="850" dirty="0"/>
           </a:p>
@@ -13772,14 +14171,14 @@
       </p:sp>
       <p:sp>
         <p:nvSpPr>
-          <p:cNvPr id="8" name="Text 5"/>
+          <p:cNvPr id="9" name="Text 6"/>
           <p:cNvSpPr/>
           <p:nvPr/>
         </p:nvSpPr>
         <p:spPr>
           <a:xfrm>
-            <a:off x="9953625" y="7267129"/>
-            <a:ext cx="685800" cy="162401"/>
+            <a:off x="495300" y="7272338"/>
+            <a:ext cx="7639050" cy="157163"/>
           </a:xfrm>
           <a:prstGeom prst="rect">
             <a:avLst/>
@@ -13793,7 +14192,66 @@
           <a:p>
             <a:pPr algn="l" indent="0" marL="0">
               <a:lnSpc>
-                <a:spcPts val="1279"/>
+                <a:spcPts val="1238"/>
+              </a:lnSpc>
+              <a:buNone/>
+            </a:pPr>
+            <a:r>
+              <a:rPr lang="en-US" sz="850" b="1" dirty="0">
+                <a:solidFill>
+                  <a:srgbClr val="222C4F"/>
+                </a:solidFill>
+                <a:latin typeface="Lato" pitchFamily="34" charset="0"/>
+                <a:ea typeface="Lato" pitchFamily="34" charset="-122"/>
+                <a:cs typeface="Lato" pitchFamily="34" charset="-120"/>
+              </a:rPr>
+              <a:t>Dudas/consultas:</a:t>
+            </a:r>
+            <a:pPr algn="l" indent="0" marL="0">
+              <a:lnSpc>
+                <a:spcPts val="1238"/>
+              </a:lnSpc>
+              <a:buNone/>
+            </a:pPr>
+            <a:r>
+              <a:rPr lang="en-US" sz="850" dirty="0">
+                <a:solidFill>
+                  <a:srgbClr val="5A6072"/>
+                </a:solidFill>
+                <a:latin typeface="Lato" pitchFamily="34" charset="0"/>
+                <a:ea typeface="Lato" pitchFamily="34" charset="-122"/>
+                <a:cs typeface="Lato" pitchFamily="34" charset="-120"/>
+              </a:rPr>
+              <a:t> emmanuel.miranda@trenesargentinos.gob.ar · fabian.alvarez@trenesargentinos.gob.ar</a:t>
+            </a:r>
+            <a:endParaRPr lang="en-US" sz="850" dirty="0"/>
+          </a:p>
+        </p:txBody>
+      </p:sp>
+      <p:sp>
+        <p:nvSpPr>
+          <p:cNvPr id="10" name="Text 7"/>
+          <p:cNvSpPr/>
+          <p:nvPr/>
+        </p:nvSpPr>
+        <p:spPr>
+          <a:xfrm>
+            <a:off x="8229600" y="7272338"/>
+            <a:ext cx="1971675" cy="157163"/>
+          </a:xfrm>
+          <a:prstGeom prst="rect">
+            <a:avLst/>
+          </a:prstGeom>
+          <a:noFill/>
+          <a:ln/>
+        </p:spPr>
+        <p:txBody>
+          <a:bodyPr wrap="none" lIns="0" tIns="0" rIns="0" bIns="0" rtlCol="0" anchor="t"/>
+          <a:lstStyle/>
+          <a:p>
+            <a:pPr algn="r" indent="0" marL="0">
+              <a:lnSpc>
+                <a:spcPts val="1238"/>
               </a:lnSpc>
               <a:buNone/>
             </a:pPr>
@@ -13806,7 +14264,7 @@
                 <a:ea typeface="Lato" pitchFamily="34" charset="-122"/>
                 <a:cs typeface="Lato" pitchFamily="34" charset="-120"/>
               </a:rPr>
-              <a:t>14 / 17</a:t>
+              <a:t>SOFSA · Presupuesto 2027 · 14 / 17</a:t>
             </a:r>
             <a:endParaRPr lang="en-US" sz="850" dirty="0"/>
           </a:p>
@@ -15810,14 +16268,34 @@
       </p:graphicFrame>
       <p:sp>
         <p:nvSpPr>
-          <p:cNvPr id="7" name="Text 4"/>
+          <p:cNvPr id="7" name="Shape 4"/>
           <p:cNvSpPr/>
           <p:nvPr/>
         </p:nvSpPr>
         <p:spPr>
           <a:xfrm>
-            <a:off x="438150" y="7267129"/>
-            <a:ext cx="8458200" cy="162401"/>
+            <a:off x="495300" y="7038975"/>
+            <a:ext cx="9705975" cy="9525"/>
+          </a:xfrm>
+          <a:prstGeom prst="rect">
+            <a:avLst/>
+          </a:prstGeom>
+          <a:solidFill>
+            <a:srgbClr val="E5E8F0"/>
+          </a:solidFill>
+          <a:ln/>
+        </p:spPr>
+      </p:sp>
+      <p:sp>
+        <p:nvSpPr>
+          <p:cNvPr id="8" name="Text 5"/>
+          <p:cNvSpPr/>
+          <p:nvPr/>
+        </p:nvSpPr>
+        <p:spPr>
+          <a:xfrm>
+            <a:off x="495300" y="7115175"/>
+            <a:ext cx="7639050" cy="157163"/>
           </a:xfrm>
           <a:prstGeom prst="rect">
             <a:avLst/>
@@ -15831,20 +16309,37 @@
           <a:p>
             <a:pPr algn="l" indent="0" marL="0">
               <a:lnSpc>
-                <a:spcPts val="1279"/>
+                <a:spcPts val="1238"/>
+              </a:lnSpc>
+              <a:buNone/>
+            </a:pPr>
+            <a:r>
+              <a:rPr lang="en-US" sz="850" b="1" dirty="0">
+                <a:solidFill>
+                  <a:srgbClr val="222C4F"/>
+                </a:solidFill>
+                <a:latin typeface="Lato" pitchFamily="34" charset="0"/>
+                <a:ea typeface="Lato" pitchFamily="34" charset="-122"/>
+                <a:cs typeface="Lato" pitchFamily="34" charset="-120"/>
+              </a:rPr>
+              <a:t>Elaborado por:</a:t>
+            </a:r>
+            <a:pPr algn="l" indent="0" marL="0">
+              <a:lnSpc>
+                <a:spcPts val="1238"/>
               </a:lnSpc>
               <a:buNone/>
             </a:pPr>
             <a:r>
               <a:rPr lang="en-US" sz="850" dirty="0">
                 <a:solidFill>
-                  <a:srgbClr val="5C6073"/>
+                  <a:srgbClr val="5A6072"/>
                 </a:solidFill>
                 <a:latin typeface="Lato" pitchFamily="34" charset="0"/>
                 <a:ea typeface="Lato" pitchFamily="34" charset="-122"/>
                 <a:cs typeface="Lato" pitchFamily="34" charset="-120"/>
               </a:rPr>
-              <a:t>SOFSA · Presupuesto 2027 · Subgerencia de Presupuesto y Control de Gestión · consultas: emmanuel.miranda@trenesargentinos.gob.ar · fabian.alvarez@trenesargentinos.gob.ar</a:t>
+              <a:t> Emmanuel Miranda, Fabián R. Álvarez · Gustavo Maida, Marlene Figueroa, Benjamín Sacido, Hernán Corro, Alejandra Quintana, Verónica Orosco</a:t>
             </a:r>
             <a:endParaRPr lang="en-US" sz="850" dirty="0"/>
           </a:p>
@@ -15852,14 +16347,14 @@
       </p:sp>
       <p:sp>
         <p:nvSpPr>
-          <p:cNvPr id="8" name="Text 5"/>
+          <p:cNvPr id="9" name="Text 6"/>
           <p:cNvSpPr/>
           <p:nvPr/>
         </p:nvSpPr>
         <p:spPr>
           <a:xfrm>
-            <a:off x="9953625" y="7267129"/>
-            <a:ext cx="685800" cy="162401"/>
+            <a:off x="495300" y="7272338"/>
+            <a:ext cx="7639050" cy="157163"/>
           </a:xfrm>
           <a:prstGeom prst="rect">
             <a:avLst/>
@@ -15873,7 +16368,66 @@
           <a:p>
             <a:pPr algn="l" indent="0" marL="0">
               <a:lnSpc>
-                <a:spcPts val="1279"/>
+                <a:spcPts val="1238"/>
+              </a:lnSpc>
+              <a:buNone/>
+            </a:pPr>
+            <a:r>
+              <a:rPr lang="en-US" sz="850" b="1" dirty="0">
+                <a:solidFill>
+                  <a:srgbClr val="222C4F"/>
+                </a:solidFill>
+                <a:latin typeface="Lato" pitchFamily="34" charset="0"/>
+                <a:ea typeface="Lato" pitchFamily="34" charset="-122"/>
+                <a:cs typeface="Lato" pitchFamily="34" charset="-120"/>
+              </a:rPr>
+              <a:t>Dudas/consultas:</a:t>
+            </a:r>
+            <a:pPr algn="l" indent="0" marL="0">
+              <a:lnSpc>
+                <a:spcPts val="1238"/>
+              </a:lnSpc>
+              <a:buNone/>
+            </a:pPr>
+            <a:r>
+              <a:rPr lang="en-US" sz="850" dirty="0">
+                <a:solidFill>
+                  <a:srgbClr val="5A6072"/>
+                </a:solidFill>
+                <a:latin typeface="Lato" pitchFamily="34" charset="0"/>
+                <a:ea typeface="Lato" pitchFamily="34" charset="-122"/>
+                <a:cs typeface="Lato" pitchFamily="34" charset="-120"/>
+              </a:rPr>
+              <a:t> emmanuel.miranda@trenesargentinos.gob.ar · fabian.alvarez@trenesargentinos.gob.ar</a:t>
+            </a:r>
+            <a:endParaRPr lang="en-US" sz="850" dirty="0"/>
+          </a:p>
+        </p:txBody>
+      </p:sp>
+      <p:sp>
+        <p:nvSpPr>
+          <p:cNvPr id="10" name="Text 7"/>
+          <p:cNvSpPr/>
+          <p:nvPr/>
+        </p:nvSpPr>
+        <p:spPr>
+          <a:xfrm>
+            <a:off x="8229600" y="7272338"/>
+            <a:ext cx="1971675" cy="157163"/>
+          </a:xfrm>
+          <a:prstGeom prst="rect">
+            <a:avLst/>
+          </a:prstGeom>
+          <a:noFill/>
+          <a:ln/>
+        </p:spPr>
+        <p:txBody>
+          <a:bodyPr wrap="none" lIns="0" tIns="0" rIns="0" bIns="0" rtlCol="0" anchor="t"/>
+          <a:lstStyle/>
+          <a:p>
+            <a:pPr algn="r" indent="0" marL="0">
+              <a:lnSpc>
+                <a:spcPts val="1238"/>
               </a:lnSpc>
               <a:buNone/>
             </a:pPr>
@@ -15886,7 +16440,7 @@
                 <a:ea typeface="Lato" pitchFamily="34" charset="-122"/>
                 <a:cs typeface="Lato" pitchFamily="34" charset="-120"/>
               </a:rPr>
-              <a:t>15 / 17</a:t>
+              <a:t>SOFSA · Presupuesto 2027 · 15 / 17</a:t>
             </a:r>
             <a:endParaRPr lang="en-US" sz="850" dirty="0"/>
           </a:p>
@@ -17890,14 +18444,34 @@
       </p:graphicFrame>
       <p:sp>
         <p:nvSpPr>
-          <p:cNvPr id="7" name="Text 4"/>
+          <p:cNvPr id="7" name="Shape 4"/>
           <p:cNvSpPr/>
           <p:nvPr/>
         </p:nvSpPr>
         <p:spPr>
           <a:xfrm>
-            <a:off x="438150" y="7267129"/>
-            <a:ext cx="8458200" cy="162401"/>
+            <a:off x="495300" y="7038975"/>
+            <a:ext cx="9705975" cy="9525"/>
+          </a:xfrm>
+          <a:prstGeom prst="rect">
+            <a:avLst/>
+          </a:prstGeom>
+          <a:solidFill>
+            <a:srgbClr val="E5E8F0"/>
+          </a:solidFill>
+          <a:ln/>
+        </p:spPr>
+      </p:sp>
+      <p:sp>
+        <p:nvSpPr>
+          <p:cNvPr id="8" name="Text 5"/>
+          <p:cNvSpPr/>
+          <p:nvPr/>
+        </p:nvSpPr>
+        <p:spPr>
+          <a:xfrm>
+            <a:off x="495300" y="7115175"/>
+            <a:ext cx="7639050" cy="157163"/>
           </a:xfrm>
           <a:prstGeom prst="rect">
             <a:avLst/>
@@ -17911,20 +18485,37 @@
           <a:p>
             <a:pPr algn="l" indent="0" marL="0">
               <a:lnSpc>
-                <a:spcPts val="1279"/>
+                <a:spcPts val="1238"/>
+              </a:lnSpc>
+              <a:buNone/>
+            </a:pPr>
+            <a:r>
+              <a:rPr lang="en-US" sz="850" b="1" dirty="0">
+                <a:solidFill>
+                  <a:srgbClr val="222C4F"/>
+                </a:solidFill>
+                <a:latin typeface="Lato" pitchFamily="34" charset="0"/>
+                <a:ea typeface="Lato" pitchFamily="34" charset="-122"/>
+                <a:cs typeface="Lato" pitchFamily="34" charset="-120"/>
+              </a:rPr>
+              <a:t>Elaborado por:</a:t>
+            </a:r>
+            <a:pPr algn="l" indent="0" marL="0">
+              <a:lnSpc>
+                <a:spcPts val="1238"/>
               </a:lnSpc>
               <a:buNone/>
             </a:pPr>
             <a:r>
               <a:rPr lang="en-US" sz="850" dirty="0">
                 <a:solidFill>
-                  <a:srgbClr val="5C6073"/>
+                  <a:srgbClr val="5A6072"/>
                 </a:solidFill>
                 <a:latin typeface="Lato" pitchFamily="34" charset="0"/>
                 <a:ea typeface="Lato" pitchFamily="34" charset="-122"/>
                 <a:cs typeface="Lato" pitchFamily="34" charset="-120"/>
               </a:rPr>
-              <a:t>SOFSA · Presupuesto 2027 · Subgerencia de Presupuesto y Control de Gestión · consultas: emmanuel.miranda@trenesargentinos.gob.ar · fabian.alvarez@trenesargentinos.gob.ar</a:t>
+              <a:t> Emmanuel Miranda, Fabián R. Álvarez · Gustavo Maida, Marlene Figueroa, Benjamín Sacido, Hernán Corro, Alejandra Quintana, Verónica Orosco</a:t>
             </a:r>
             <a:endParaRPr lang="en-US" sz="850" dirty="0"/>
           </a:p>
@@ -17932,14 +18523,14 @@
       </p:sp>
       <p:sp>
         <p:nvSpPr>
-          <p:cNvPr id="8" name="Text 5"/>
+          <p:cNvPr id="9" name="Text 6"/>
           <p:cNvSpPr/>
           <p:nvPr/>
         </p:nvSpPr>
         <p:spPr>
           <a:xfrm>
-            <a:off x="9953625" y="7267129"/>
-            <a:ext cx="685800" cy="162401"/>
+            <a:off x="495300" y="7272338"/>
+            <a:ext cx="7639050" cy="157163"/>
           </a:xfrm>
           <a:prstGeom prst="rect">
             <a:avLst/>
@@ -17953,7 +18544,66 @@
           <a:p>
             <a:pPr algn="l" indent="0" marL="0">
               <a:lnSpc>
-                <a:spcPts val="1279"/>
+                <a:spcPts val="1238"/>
+              </a:lnSpc>
+              <a:buNone/>
+            </a:pPr>
+            <a:r>
+              <a:rPr lang="en-US" sz="850" b="1" dirty="0">
+                <a:solidFill>
+                  <a:srgbClr val="222C4F"/>
+                </a:solidFill>
+                <a:latin typeface="Lato" pitchFamily="34" charset="0"/>
+                <a:ea typeface="Lato" pitchFamily="34" charset="-122"/>
+                <a:cs typeface="Lato" pitchFamily="34" charset="-120"/>
+              </a:rPr>
+              <a:t>Dudas/consultas:</a:t>
+            </a:r>
+            <a:pPr algn="l" indent="0" marL="0">
+              <a:lnSpc>
+                <a:spcPts val="1238"/>
+              </a:lnSpc>
+              <a:buNone/>
+            </a:pPr>
+            <a:r>
+              <a:rPr lang="en-US" sz="850" dirty="0">
+                <a:solidFill>
+                  <a:srgbClr val="5A6072"/>
+                </a:solidFill>
+                <a:latin typeface="Lato" pitchFamily="34" charset="0"/>
+                <a:ea typeface="Lato" pitchFamily="34" charset="-122"/>
+                <a:cs typeface="Lato" pitchFamily="34" charset="-120"/>
+              </a:rPr>
+              <a:t> emmanuel.miranda@trenesargentinos.gob.ar · fabian.alvarez@trenesargentinos.gob.ar</a:t>
+            </a:r>
+            <a:endParaRPr lang="en-US" sz="850" dirty="0"/>
+          </a:p>
+        </p:txBody>
+      </p:sp>
+      <p:sp>
+        <p:nvSpPr>
+          <p:cNvPr id="10" name="Text 7"/>
+          <p:cNvSpPr/>
+          <p:nvPr/>
+        </p:nvSpPr>
+        <p:spPr>
+          <a:xfrm>
+            <a:off x="8229600" y="7272338"/>
+            <a:ext cx="1971675" cy="157163"/>
+          </a:xfrm>
+          <a:prstGeom prst="rect">
+            <a:avLst/>
+          </a:prstGeom>
+          <a:noFill/>
+          <a:ln/>
+        </p:spPr>
+        <p:txBody>
+          <a:bodyPr wrap="none" lIns="0" tIns="0" rIns="0" bIns="0" rtlCol="0" anchor="t"/>
+          <a:lstStyle/>
+          <a:p>
+            <a:pPr algn="r" indent="0" marL="0">
+              <a:lnSpc>
+                <a:spcPts val="1238"/>
               </a:lnSpc>
               <a:buNone/>
             </a:pPr>
@@ -17966,7 +18616,7 @@
                 <a:ea typeface="Lato" pitchFamily="34" charset="-122"/>
                 <a:cs typeface="Lato" pitchFamily="34" charset="-120"/>
               </a:rPr>
-              <a:t>16 / 17</a:t>
+              <a:t>SOFSA · Presupuesto 2027 · 16 / 17</a:t>
             </a:r>
             <a:endParaRPr lang="en-US" sz="850" dirty="0"/>
           </a:p>
@@ -18052,8 +18702,8 @@
         </p:nvSpPr>
         <p:spPr>
           <a:xfrm>
-            <a:off x="57150" y="114300"/>
-            <a:ext cx="10582275" cy="7391400"/>
+            <a:off x="0" y="57150"/>
+            <a:ext cx="10696575" cy="7505700"/>
           </a:xfrm>
           <a:prstGeom prst="rect">
             <a:avLst/>
@@ -18072,8 +18722,8 @@
         </p:nvSpPr>
         <p:spPr>
           <a:xfrm>
-            <a:off x="628650" y="1943249"/>
-            <a:ext cx="9820275" cy="177165"/>
+            <a:off x="571500" y="2281386"/>
+            <a:ext cx="9934575" cy="177165"/>
           </a:xfrm>
           <a:prstGeom prst="rect">
             <a:avLst/>
@@ -18114,8 +18764,8 @@
         </p:nvSpPr>
         <p:spPr>
           <a:xfrm>
-            <a:off x="628650" y="2215604"/>
-            <a:ext cx="9820275" cy="1062990"/>
+            <a:off x="571500" y="2553742"/>
+            <a:ext cx="9934575" cy="1062990"/>
           </a:xfrm>
           <a:prstGeom prst="rect">
             <a:avLst/>
@@ -18156,7 +18806,7 @@
         </p:nvSpPr>
         <p:spPr>
           <a:xfrm>
-            <a:off x="628650" y="3373785"/>
+            <a:off x="571500" y="3711922"/>
             <a:ext cx="8248650" cy="839837"/>
           </a:xfrm>
           <a:prstGeom prst="rect">
@@ -18198,8 +18848,8 @@
         </p:nvSpPr>
         <p:spPr>
           <a:xfrm>
-            <a:off x="628650" y="4537472"/>
-            <a:ext cx="9820275" cy="177165"/>
+            <a:off x="571500" y="4875609"/>
+            <a:ext cx="9934575" cy="177165"/>
           </a:xfrm>
           <a:prstGeom prst="rect">
             <a:avLst/>
@@ -18234,62 +18884,23 @@
       </p:sp>
       <p:sp>
         <p:nvSpPr>
-          <p:cNvPr id="9" name="Text 7"/>
+          <p:cNvPr id="9" name="Shape 7"/>
           <p:cNvSpPr/>
           <p:nvPr/>
         </p:nvSpPr>
         <p:spPr>
           <a:xfrm>
-            <a:off x="628650" y="5105102"/>
-            <a:ext cx="8629650" cy="381000"/>
+            <a:off x="495300" y="7038975"/>
+            <a:ext cx="9705975" cy="9525"/>
           </a:xfrm>
           <a:prstGeom prst="rect">
             <a:avLst/>
           </a:prstGeom>
-          <a:noFill/>
+          <a:solidFill>
+            <a:srgbClr val="E3EBF6"/>
+          </a:solidFill>
           <a:ln/>
         </p:spPr>
-        <p:txBody>
-          <a:bodyPr wrap="square" lIns="0" tIns="0" rIns="0" bIns="0" rtlCol="0" anchor="t"/>
-          <a:lstStyle/>
-          <a:p>
-            <a:pPr algn="l" indent="0" marL="0">
-              <a:lnSpc>
-                <a:spcPts val="1500"/>
-              </a:lnSpc>
-              <a:buNone/>
-            </a:pPr>
-            <a:r>
-              <a:rPr lang="en-US" sz="950" b="1" dirty="0">
-                <a:solidFill>
-                  <a:srgbClr val="E7B860"/>
-                </a:solidFill>
-                <a:latin typeface="Lato" pitchFamily="34" charset="0"/>
-                <a:ea typeface="Lato" pitchFamily="34" charset="-122"/>
-                <a:cs typeface="Lato" pitchFamily="34" charset="-120"/>
-              </a:rPr>
-              <a:t>Elaborado por:</a:t>
-            </a:r>
-            <a:pPr algn="l" indent="0" marL="0">
-              <a:lnSpc>
-                <a:spcPts val="1500"/>
-              </a:lnSpc>
-              <a:buNone/>
-            </a:pPr>
-            <a:r>
-              <a:rPr lang="en-US" sz="950" dirty="0">
-                <a:solidFill>
-                  <a:srgbClr val="D8E3F2"/>
-                </a:solidFill>
-                <a:latin typeface="Lato" pitchFamily="34" charset="0"/>
-                <a:ea typeface="Lato" pitchFamily="34" charset="-122"/>
-                <a:cs typeface="Lato" pitchFamily="34" charset="-120"/>
-              </a:rPr>
-              <a:t> Emmanuel Miranda, Fabián R. Álvarez · Gustavo Maida, Marlene Figueroa, Benjamín Sacido, Hernán Corro, Alejandra Quintana, Verónica Orosco</a:t>
-            </a:r>
-            <a:endParaRPr lang="en-US" sz="950" dirty="0"/>
-          </a:p>
-        </p:txBody>
       </p:sp>
       <p:sp>
         <p:nvSpPr>
@@ -18299,8 +18910,8 @@
         </p:nvSpPr>
         <p:spPr>
           <a:xfrm>
-            <a:off x="628650" y="5486102"/>
-            <a:ext cx="8953500" cy="190500"/>
+            <a:off x="495300" y="7115175"/>
+            <a:ext cx="7639050" cy="157163"/>
           </a:xfrm>
           <a:prstGeom prst="rect">
             <a:avLst/>
@@ -18314,12 +18925,12 @@
           <a:p>
             <a:pPr algn="l" indent="0" marL="0">
               <a:lnSpc>
-                <a:spcPts val="1500"/>
+                <a:spcPts val="1238"/>
               </a:lnSpc>
               <a:buNone/>
             </a:pPr>
             <a:r>
-              <a:rPr lang="en-US" sz="950" b="1" dirty="0">
+              <a:rPr lang="en-US" sz="850" b="1" dirty="0">
                 <a:solidFill>
                   <a:srgbClr val="E7B860"/>
                 </a:solidFill>
@@ -18327,16 +18938,16 @@
                 <a:ea typeface="Lato" pitchFamily="34" charset="-122"/>
                 <a:cs typeface="Lato" pitchFamily="34" charset="-120"/>
               </a:rPr>
-              <a:t>Dudas/consultas:</a:t>
+              <a:t>Elaborado por:</a:t>
             </a:r>
             <a:pPr algn="l" indent="0" marL="0">
               <a:lnSpc>
-                <a:spcPts val="1500"/>
+                <a:spcPts val="1238"/>
               </a:lnSpc>
               <a:buNone/>
             </a:pPr>
             <a:r>
-              <a:rPr lang="en-US" sz="950" dirty="0">
+              <a:rPr lang="en-US" sz="850" dirty="0">
                 <a:solidFill>
                   <a:srgbClr val="D8E3F2"/>
                 </a:solidFill>
@@ -18344,9 +18955,9 @@
                 <a:ea typeface="Lato" pitchFamily="34" charset="-122"/>
                 <a:cs typeface="Lato" pitchFamily="34" charset="-120"/>
               </a:rPr>
-              <a:t> emmanuel.miranda@trenesargentinos.gob.ar · fabian.alvarez@trenesargentinos.gob.ar</a:t>
+              <a:t> Emmanuel Miranda, Fabián R. Álvarez · Gustavo Maida, Marlene Figueroa, Benjamín Sacido, Hernán Corro, Alejandra Quintana, Verónica Orosco</a:t>
             </a:r>
-            <a:endParaRPr lang="en-US" sz="950" dirty="0"/>
+            <a:endParaRPr lang="en-US" sz="850" dirty="0"/>
           </a:p>
         </p:txBody>
       </p:sp>
@@ -18358,8 +18969,8 @@
         </p:nvSpPr>
         <p:spPr>
           <a:xfrm>
-            <a:off x="438150" y="7267129"/>
-            <a:ext cx="8458200" cy="162401"/>
+            <a:off x="495300" y="7272338"/>
+            <a:ext cx="7639050" cy="157163"/>
           </a:xfrm>
           <a:prstGeom prst="rect">
             <a:avLst/>
@@ -18373,20 +18984,37 @@
           <a:p>
             <a:pPr algn="l" indent="0" marL="0">
               <a:lnSpc>
-                <a:spcPts val="1279"/>
+                <a:spcPts val="1238"/>
+              </a:lnSpc>
+              <a:buNone/>
+            </a:pPr>
+            <a:r>
+              <a:rPr lang="en-US" sz="850" b="1" dirty="0">
+                <a:solidFill>
+                  <a:srgbClr val="E7B860"/>
+                </a:solidFill>
+                <a:latin typeface="Lato" pitchFamily="34" charset="0"/>
+                <a:ea typeface="Lato" pitchFamily="34" charset="-122"/>
+                <a:cs typeface="Lato" pitchFamily="34" charset="-120"/>
+              </a:rPr>
+              <a:t>Dudas/consultas:</a:t>
+            </a:r>
+            <a:pPr algn="l" indent="0" marL="0">
+              <a:lnSpc>
+                <a:spcPts val="1238"/>
               </a:lnSpc>
               <a:buNone/>
             </a:pPr>
             <a:r>
               <a:rPr lang="en-US" sz="850" dirty="0">
                 <a:solidFill>
-                  <a:srgbClr val="AEC6E4"/>
+                  <a:srgbClr val="D8E3F2"/>
                 </a:solidFill>
                 <a:latin typeface="Lato" pitchFamily="34" charset="0"/>
                 <a:ea typeface="Lato" pitchFamily="34" charset="-122"/>
                 <a:cs typeface="Lato" pitchFamily="34" charset="-120"/>
               </a:rPr>
-              <a:t>SOFSA · Presupuesto 2027 · Subgerencia de Presupuesto y Control de Gestión · consultas: emmanuel.miranda@trenesargentinos.gob.ar · fabian.alvarez@trenesargentinos.gob.ar</a:t>
+              <a:t> emmanuel.miranda@trenesargentinos.gob.ar · fabian.alvarez@trenesargentinos.gob.ar</a:t>
             </a:r>
             <a:endParaRPr lang="en-US" sz="850" dirty="0"/>
           </a:p>
@@ -18400,8 +19028,8 @@
         </p:nvSpPr>
         <p:spPr>
           <a:xfrm>
-            <a:off x="9953625" y="7267129"/>
-            <a:ext cx="685800" cy="162401"/>
+            <a:off x="8229600" y="7272338"/>
+            <a:ext cx="1971675" cy="157163"/>
           </a:xfrm>
           <a:prstGeom prst="rect">
             <a:avLst/>
@@ -18413,9 +19041,9 @@
           <a:bodyPr wrap="none" lIns="0" tIns="0" rIns="0" bIns="0" rtlCol="0" anchor="t"/>
           <a:lstStyle/>
           <a:p>
-            <a:pPr algn="l" indent="0" marL="0">
+            <a:pPr algn="r" indent="0" marL="0">
               <a:lnSpc>
-                <a:spcPts val="1279"/>
+                <a:spcPts val="1238"/>
               </a:lnSpc>
               <a:buNone/>
             </a:pPr>
@@ -18428,7 +19056,7 @@
                 <a:ea typeface="Lato" pitchFamily="34" charset="-122"/>
                 <a:cs typeface="Lato" pitchFamily="34" charset="-120"/>
               </a:rPr>
-              <a:t>17 / 17</a:t>
+              <a:t>SOFSA · Presupuesto 2027 · 17 / 17</a:t>
             </a:r>
             <a:endParaRPr lang="en-US" sz="850" dirty="0"/>
           </a:p>
@@ -20037,14 +20665,34 @@
       </p:sp>
       <p:sp>
         <p:nvSpPr>
-          <p:cNvPr id="43" name="Text 41"/>
+          <p:cNvPr id="43" name="Shape 41"/>
           <p:cNvSpPr/>
           <p:nvPr/>
         </p:nvSpPr>
         <p:spPr>
           <a:xfrm>
-            <a:off x="438150" y="7267129"/>
-            <a:ext cx="8458200" cy="162401"/>
+            <a:off x="495300" y="7038975"/>
+            <a:ext cx="9705975" cy="9525"/>
+          </a:xfrm>
+          <a:prstGeom prst="rect">
+            <a:avLst/>
+          </a:prstGeom>
+          <a:solidFill>
+            <a:srgbClr val="E5E8F0"/>
+          </a:solidFill>
+          <a:ln/>
+        </p:spPr>
+      </p:sp>
+      <p:sp>
+        <p:nvSpPr>
+          <p:cNvPr id="44" name="Text 42"/>
+          <p:cNvSpPr/>
+          <p:nvPr/>
+        </p:nvSpPr>
+        <p:spPr>
+          <a:xfrm>
+            <a:off x="495300" y="7115175"/>
+            <a:ext cx="7639050" cy="157163"/>
           </a:xfrm>
           <a:prstGeom prst="rect">
             <a:avLst/>
@@ -20058,20 +20706,37 @@
           <a:p>
             <a:pPr algn="l" indent="0" marL="0">
               <a:lnSpc>
-                <a:spcPts val="1279"/>
+                <a:spcPts val="1238"/>
+              </a:lnSpc>
+              <a:buNone/>
+            </a:pPr>
+            <a:r>
+              <a:rPr lang="en-US" sz="850" b="1" dirty="0">
+                <a:solidFill>
+                  <a:srgbClr val="222C4F"/>
+                </a:solidFill>
+                <a:latin typeface="Lato" pitchFamily="34" charset="0"/>
+                <a:ea typeface="Lato" pitchFamily="34" charset="-122"/>
+                <a:cs typeface="Lato" pitchFamily="34" charset="-120"/>
+              </a:rPr>
+              <a:t>Elaborado por:</a:t>
+            </a:r>
+            <a:pPr algn="l" indent="0" marL="0">
+              <a:lnSpc>
+                <a:spcPts val="1238"/>
               </a:lnSpc>
               <a:buNone/>
             </a:pPr>
             <a:r>
               <a:rPr lang="en-US" sz="850" dirty="0">
                 <a:solidFill>
-                  <a:srgbClr val="5C6073"/>
+                  <a:srgbClr val="5A6072"/>
                 </a:solidFill>
                 <a:latin typeface="Lato" pitchFamily="34" charset="0"/>
                 <a:ea typeface="Lato" pitchFamily="34" charset="-122"/>
                 <a:cs typeface="Lato" pitchFamily="34" charset="-120"/>
               </a:rPr>
-              <a:t>SOFSA · Presupuesto 2027 · Subgerencia de Presupuesto y Control de Gestión · consultas: emmanuel.miranda@trenesargentinos.gob.ar · fabian.alvarez@trenesargentinos.gob.ar</a:t>
+              <a:t> Emmanuel Miranda, Fabián R. Álvarez · Gustavo Maida, Marlene Figueroa, Benjamín Sacido, Hernán Corro, Alejandra Quintana, Verónica Orosco</a:t>
             </a:r>
             <a:endParaRPr lang="en-US" sz="850" dirty="0"/>
           </a:p>
@@ -20079,14 +20744,14 @@
       </p:sp>
       <p:sp>
         <p:nvSpPr>
-          <p:cNvPr id="44" name="Text 42"/>
+          <p:cNvPr id="45" name="Text 43"/>
           <p:cNvSpPr/>
           <p:nvPr/>
         </p:nvSpPr>
         <p:spPr>
           <a:xfrm>
-            <a:off x="10010775" y="7267129"/>
-            <a:ext cx="628650" cy="162401"/>
+            <a:off x="495300" y="7272338"/>
+            <a:ext cx="7639050" cy="157163"/>
           </a:xfrm>
           <a:prstGeom prst="rect">
             <a:avLst/>
@@ -20100,7 +20765,66 @@
           <a:p>
             <a:pPr algn="l" indent="0" marL="0">
               <a:lnSpc>
-                <a:spcPts val="1279"/>
+                <a:spcPts val="1238"/>
+              </a:lnSpc>
+              <a:buNone/>
+            </a:pPr>
+            <a:r>
+              <a:rPr lang="en-US" sz="850" b="1" dirty="0">
+                <a:solidFill>
+                  <a:srgbClr val="222C4F"/>
+                </a:solidFill>
+                <a:latin typeface="Lato" pitchFamily="34" charset="0"/>
+                <a:ea typeface="Lato" pitchFamily="34" charset="-122"/>
+                <a:cs typeface="Lato" pitchFamily="34" charset="-120"/>
+              </a:rPr>
+              <a:t>Dudas/consultas:</a:t>
+            </a:r>
+            <a:pPr algn="l" indent="0" marL="0">
+              <a:lnSpc>
+                <a:spcPts val="1238"/>
+              </a:lnSpc>
+              <a:buNone/>
+            </a:pPr>
+            <a:r>
+              <a:rPr lang="en-US" sz="850" dirty="0">
+                <a:solidFill>
+                  <a:srgbClr val="5A6072"/>
+                </a:solidFill>
+                <a:latin typeface="Lato" pitchFamily="34" charset="0"/>
+                <a:ea typeface="Lato" pitchFamily="34" charset="-122"/>
+                <a:cs typeface="Lato" pitchFamily="34" charset="-120"/>
+              </a:rPr>
+              <a:t> emmanuel.miranda@trenesargentinos.gob.ar · fabian.alvarez@trenesargentinos.gob.ar</a:t>
+            </a:r>
+            <a:endParaRPr lang="en-US" sz="850" dirty="0"/>
+          </a:p>
+        </p:txBody>
+      </p:sp>
+      <p:sp>
+        <p:nvSpPr>
+          <p:cNvPr id="46" name="Text 44"/>
+          <p:cNvSpPr/>
+          <p:nvPr/>
+        </p:nvSpPr>
+        <p:spPr>
+          <a:xfrm>
+            <a:off x="8286750" y="7272338"/>
+            <a:ext cx="1914525" cy="157163"/>
+          </a:xfrm>
+          <a:prstGeom prst="rect">
+            <a:avLst/>
+          </a:prstGeom>
+          <a:noFill/>
+          <a:ln/>
+        </p:spPr>
+        <p:txBody>
+          <a:bodyPr wrap="none" lIns="0" tIns="0" rIns="0" bIns="0" rtlCol="0" anchor="t"/>
+          <a:lstStyle/>
+          <a:p>
+            <a:pPr algn="r" indent="0" marL="0">
+              <a:lnSpc>
+                <a:spcPts val="1238"/>
               </a:lnSpc>
               <a:buNone/>
             </a:pPr>
@@ -20113,7 +20837,7 @@
                 <a:ea typeface="Lato" pitchFamily="34" charset="-122"/>
                 <a:cs typeface="Lato" pitchFamily="34" charset="-120"/>
               </a:rPr>
-              <a:t>2 / 17</a:t>
+              <a:t>SOFSA · Presupuesto 2027 · 2 / 17</a:t>
             </a:r>
             <a:endParaRPr lang="en-US" sz="850" dirty="0"/>
           </a:p>
@@ -23316,14 +24040,34 @@
       </p:sp>
       <p:sp>
         <p:nvSpPr>
-          <p:cNvPr id="39" name="Text 35"/>
+          <p:cNvPr id="39" name="Shape 35"/>
           <p:cNvSpPr/>
           <p:nvPr/>
         </p:nvSpPr>
         <p:spPr>
           <a:xfrm>
-            <a:off x="438150" y="7267129"/>
-            <a:ext cx="8458200" cy="162401"/>
+            <a:off x="495300" y="7038975"/>
+            <a:ext cx="9705975" cy="9525"/>
+          </a:xfrm>
+          <a:prstGeom prst="rect">
+            <a:avLst/>
+          </a:prstGeom>
+          <a:solidFill>
+            <a:srgbClr val="E5E8F0"/>
+          </a:solidFill>
+          <a:ln/>
+        </p:spPr>
+      </p:sp>
+      <p:sp>
+        <p:nvSpPr>
+          <p:cNvPr id="40" name="Text 36"/>
+          <p:cNvSpPr/>
+          <p:nvPr/>
+        </p:nvSpPr>
+        <p:spPr>
+          <a:xfrm>
+            <a:off x="495300" y="7115175"/>
+            <a:ext cx="7639050" cy="157163"/>
           </a:xfrm>
           <a:prstGeom prst="rect">
             <a:avLst/>
@@ -23337,20 +24081,37 @@
           <a:p>
             <a:pPr algn="l" indent="0" marL="0">
               <a:lnSpc>
-                <a:spcPts val="1279"/>
+                <a:spcPts val="1238"/>
+              </a:lnSpc>
+              <a:buNone/>
+            </a:pPr>
+            <a:r>
+              <a:rPr lang="en-US" sz="850" b="1" dirty="0">
+                <a:solidFill>
+                  <a:srgbClr val="222C4F"/>
+                </a:solidFill>
+                <a:latin typeface="Lato" pitchFamily="34" charset="0"/>
+                <a:ea typeface="Lato" pitchFamily="34" charset="-122"/>
+                <a:cs typeface="Lato" pitchFamily="34" charset="-120"/>
+              </a:rPr>
+              <a:t>Elaborado por:</a:t>
+            </a:r>
+            <a:pPr algn="l" indent="0" marL="0">
+              <a:lnSpc>
+                <a:spcPts val="1238"/>
               </a:lnSpc>
               <a:buNone/>
             </a:pPr>
             <a:r>
               <a:rPr lang="en-US" sz="850" dirty="0">
                 <a:solidFill>
-                  <a:srgbClr val="5C6073"/>
+                  <a:srgbClr val="5A6072"/>
                 </a:solidFill>
                 <a:latin typeface="Lato" pitchFamily="34" charset="0"/>
                 <a:ea typeface="Lato" pitchFamily="34" charset="-122"/>
                 <a:cs typeface="Lato" pitchFamily="34" charset="-120"/>
               </a:rPr>
-              <a:t>SOFSA · Presupuesto 2027 · Subgerencia de Presupuesto y Control de Gestión · consultas: emmanuel.miranda@trenesargentinos.gob.ar · fabian.alvarez@trenesargentinos.gob.ar</a:t>
+              <a:t> Emmanuel Miranda, Fabián R. Álvarez · Gustavo Maida, Marlene Figueroa, Benjamín Sacido, Hernán Corro, Alejandra Quintana, Verónica Orosco</a:t>
             </a:r>
             <a:endParaRPr lang="en-US" sz="850" dirty="0"/>
           </a:p>
@@ -23358,14 +24119,14 @@
       </p:sp>
       <p:sp>
         <p:nvSpPr>
-          <p:cNvPr id="40" name="Text 36"/>
+          <p:cNvPr id="41" name="Text 37"/>
           <p:cNvSpPr/>
           <p:nvPr/>
         </p:nvSpPr>
         <p:spPr>
           <a:xfrm>
-            <a:off x="10010775" y="7267129"/>
-            <a:ext cx="628650" cy="162401"/>
+            <a:off x="495300" y="7272338"/>
+            <a:ext cx="7639050" cy="157163"/>
           </a:xfrm>
           <a:prstGeom prst="rect">
             <a:avLst/>
@@ -23379,7 +24140,66 @@
           <a:p>
             <a:pPr algn="l" indent="0" marL="0">
               <a:lnSpc>
-                <a:spcPts val="1279"/>
+                <a:spcPts val="1238"/>
+              </a:lnSpc>
+              <a:buNone/>
+            </a:pPr>
+            <a:r>
+              <a:rPr lang="en-US" sz="850" b="1" dirty="0">
+                <a:solidFill>
+                  <a:srgbClr val="222C4F"/>
+                </a:solidFill>
+                <a:latin typeface="Lato" pitchFamily="34" charset="0"/>
+                <a:ea typeface="Lato" pitchFamily="34" charset="-122"/>
+                <a:cs typeface="Lato" pitchFamily="34" charset="-120"/>
+              </a:rPr>
+              <a:t>Dudas/consultas:</a:t>
+            </a:r>
+            <a:pPr algn="l" indent="0" marL="0">
+              <a:lnSpc>
+                <a:spcPts val="1238"/>
+              </a:lnSpc>
+              <a:buNone/>
+            </a:pPr>
+            <a:r>
+              <a:rPr lang="en-US" sz="850" dirty="0">
+                <a:solidFill>
+                  <a:srgbClr val="5A6072"/>
+                </a:solidFill>
+                <a:latin typeface="Lato" pitchFamily="34" charset="0"/>
+                <a:ea typeface="Lato" pitchFamily="34" charset="-122"/>
+                <a:cs typeface="Lato" pitchFamily="34" charset="-120"/>
+              </a:rPr>
+              <a:t> emmanuel.miranda@trenesargentinos.gob.ar · fabian.alvarez@trenesargentinos.gob.ar</a:t>
+            </a:r>
+            <a:endParaRPr lang="en-US" sz="850" dirty="0"/>
+          </a:p>
+        </p:txBody>
+      </p:sp>
+      <p:sp>
+        <p:nvSpPr>
+          <p:cNvPr id="42" name="Text 38"/>
+          <p:cNvSpPr/>
+          <p:nvPr/>
+        </p:nvSpPr>
+        <p:spPr>
+          <a:xfrm>
+            <a:off x="8286750" y="7272338"/>
+            <a:ext cx="1914525" cy="157163"/>
+          </a:xfrm>
+          <a:prstGeom prst="rect">
+            <a:avLst/>
+          </a:prstGeom>
+          <a:noFill/>
+          <a:ln/>
+        </p:spPr>
+        <p:txBody>
+          <a:bodyPr wrap="none" lIns="0" tIns="0" rIns="0" bIns="0" rtlCol="0" anchor="t"/>
+          <a:lstStyle/>
+          <a:p>
+            <a:pPr algn="r" indent="0" marL="0">
+              <a:lnSpc>
+                <a:spcPts val="1238"/>
               </a:lnSpc>
               <a:buNone/>
             </a:pPr>
@@ -23392,7 +24212,7 @@
                 <a:ea typeface="Lato" pitchFamily="34" charset="-122"/>
                 <a:cs typeface="Lato" pitchFamily="34" charset="-120"/>
               </a:rPr>
-              <a:t>3 / 17</a:t>
+              <a:t>SOFSA · Presupuesto 2027 · 3 / 17</a:t>
             </a:r>
             <a:endParaRPr lang="en-US" sz="850" dirty="0"/>
           </a:p>
@@ -23620,14 +24440,34 @@
       </p:sp>
       <p:sp>
         <p:nvSpPr>
-          <p:cNvPr id="9" name="Text 6"/>
+          <p:cNvPr id="9" name="Shape 6"/>
           <p:cNvSpPr/>
           <p:nvPr/>
         </p:nvSpPr>
         <p:spPr>
           <a:xfrm>
-            <a:off x="438150" y="7267129"/>
-            <a:ext cx="8458200" cy="162401"/>
+            <a:off x="495300" y="7038975"/>
+            <a:ext cx="9705975" cy="9525"/>
+          </a:xfrm>
+          <a:prstGeom prst="rect">
+            <a:avLst/>
+          </a:prstGeom>
+          <a:solidFill>
+            <a:srgbClr val="E5E8F0"/>
+          </a:solidFill>
+          <a:ln/>
+        </p:spPr>
+      </p:sp>
+      <p:sp>
+        <p:nvSpPr>
+          <p:cNvPr id="10" name="Text 7"/>
+          <p:cNvSpPr/>
+          <p:nvPr/>
+        </p:nvSpPr>
+        <p:spPr>
+          <a:xfrm>
+            <a:off x="495300" y="7115175"/>
+            <a:ext cx="7639050" cy="157163"/>
           </a:xfrm>
           <a:prstGeom prst="rect">
             <a:avLst/>
@@ -23641,20 +24481,37 @@
           <a:p>
             <a:pPr algn="l" indent="0" marL="0">
               <a:lnSpc>
-                <a:spcPts val="1279"/>
+                <a:spcPts val="1238"/>
+              </a:lnSpc>
+              <a:buNone/>
+            </a:pPr>
+            <a:r>
+              <a:rPr lang="en-US" sz="850" b="1" dirty="0">
+                <a:solidFill>
+                  <a:srgbClr val="222C4F"/>
+                </a:solidFill>
+                <a:latin typeface="Lato" pitchFamily="34" charset="0"/>
+                <a:ea typeface="Lato" pitchFamily="34" charset="-122"/>
+                <a:cs typeface="Lato" pitchFamily="34" charset="-120"/>
+              </a:rPr>
+              <a:t>Elaborado por:</a:t>
+            </a:r>
+            <a:pPr algn="l" indent="0" marL="0">
+              <a:lnSpc>
+                <a:spcPts val="1238"/>
               </a:lnSpc>
               <a:buNone/>
             </a:pPr>
             <a:r>
               <a:rPr lang="en-US" sz="850" dirty="0">
                 <a:solidFill>
-                  <a:srgbClr val="5C6073"/>
+                  <a:srgbClr val="5A6072"/>
                 </a:solidFill>
                 <a:latin typeface="Lato" pitchFamily="34" charset="0"/>
                 <a:ea typeface="Lato" pitchFamily="34" charset="-122"/>
                 <a:cs typeface="Lato" pitchFamily="34" charset="-120"/>
               </a:rPr>
-              <a:t>SOFSA · Presupuesto 2027 · Subgerencia de Presupuesto y Control de Gestión · consultas: emmanuel.miranda@trenesargentinos.gob.ar · fabian.alvarez@trenesargentinos.gob.ar</a:t>
+              <a:t> Emmanuel Miranda, Fabián R. Álvarez · Gustavo Maida, Marlene Figueroa, Benjamín Sacido, Hernán Corro, Alejandra Quintana, Verónica Orosco</a:t>
             </a:r>
             <a:endParaRPr lang="en-US" sz="850" dirty="0"/>
           </a:p>
@@ -23662,14 +24519,14 @@
       </p:sp>
       <p:sp>
         <p:nvSpPr>
-          <p:cNvPr id="10" name="Text 7"/>
+          <p:cNvPr id="11" name="Text 8"/>
           <p:cNvSpPr/>
           <p:nvPr/>
         </p:nvSpPr>
         <p:spPr>
           <a:xfrm>
-            <a:off x="10010775" y="7267129"/>
-            <a:ext cx="628650" cy="162401"/>
+            <a:off x="495300" y="7272338"/>
+            <a:ext cx="7639050" cy="157163"/>
           </a:xfrm>
           <a:prstGeom prst="rect">
             <a:avLst/>
@@ -23683,7 +24540,66 @@
           <a:p>
             <a:pPr algn="l" indent="0" marL="0">
               <a:lnSpc>
-                <a:spcPts val="1279"/>
+                <a:spcPts val="1238"/>
+              </a:lnSpc>
+              <a:buNone/>
+            </a:pPr>
+            <a:r>
+              <a:rPr lang="en-US" sz="850" b="1" dirty="0">
+                <a:solidFill>
+                  <a:srgbClr val="222C4F"/>
+                </a:solidFill>
+                <a:latin typeface="Lato" pitchFamily="34" charset="0"/>
+                <a:ea typeface="Lato" pitchFamily="34" charset="-122"/>
+                <a:cs typeface="Lato" pitchFamily="34" charset="-120"/>
+              </a:rPr>
+              <a:t>Dudas/consultas:</a:t>
+            </a:r>
+            <a:pPr algn="l" indent="0" marL="0">
+              <a:lnSpc>
+                <a:spcPts val="1238"/>
+              </a:lnSpc>
+              <a:buNone/>
+            </a:pPr>
+            <a:r>
+              <a:rPr lang="en-US" sz="850" dirty="0">
+                <a:solidFill>
+                  <a:srgbClr val="5A6072"/>
+                </a:solidFill>
+                <a:latin typeface="Lato" pitchFamily="34" charset="0"/>
+                <a:ea typeface="Lato" pitchFamily="34" charset="-122"/>
+                <a:cs typeface="Lato" pitchFamily="34" charset="-120"/>
+              </a:rPr>
+              <a:t> emmanuel.miranda@trenesargentinos.gob.ar · fabian.alvarez@trenesargentinos.gob.ar</a:t>
+            </a:r>
+            <a:endParaRPr lang="en-US" sz="850" dirty="0"/>
+          </a:p>
+        </p:txBody>
+      </p:sp>
+      <p:sp>
+        <p:nvSpPr>
+          <p:cNvPr id="12" name="Text 9"/>
+          <p:cNvSpPr/>
+          <p:nvPr/>
+        </p:nvSpPr>
+        <p:spPr>
+          <a:xfrm>
+            <a:off x="8286750" y="7272338"/>
+            <a:ext cx="1914525" cy="157163"/>
+          </a:xfrm>
+          <a:prstGeom prst="rect">
+            <a:avLst/>
+          </a:prstGeom>
+          <a:noFill/>
+          <a:ln/>
+        </p:spPr>
+        <p:txBody>
+          <a:bodyPr wrap="none" lIns="0" tIns="0" rIns="0" bIns="0" rtlCol="0" anchor="t"/>
+          <a:lstStyle/>
+          <a:p>
+            <a:pPr algn="r" indent="0" marL="0">
+              <a:lnSpc>
+                <a:spcPts val="1238"/>
               </a:lnSpc>
               <a:buNone/>
             </a:pPr>
@@ -23696,7 +24612,7 @@
                 <a:ea typeface="Lato" pitchFamily="34" charset="-122"/>
                 <a:cs typeface="Lato" pitchFamily="34" charset="-120"/>
               </a:rPr>
-              <a:t>4 / 17</a:t>
+              <a:t>SOFSA · Presupuesto 2027 · 4 / 17</a:t>
             </a:r>
             <a:endParaRPr lang="en-US" sz="850" dirty="0"/>
           </a:p>
@@ -28218,14 +29134,34 @@
       </p:sp>
       <p:sp>
         <p:nvSpPr>
-          <p:cNvPr id="29" name="Text 26"/>
+          <p:cNvPr id="29" name="Shape 26"/>
           <p:cNvSpPr/>
           <p:nvPr/>
         </p:nvSpPr>
         <p:spPr>
           <a:xfrm>
-            <a:off x="438150" y="7267129"/>
-            <a:ext cx="8458200" cy="162401"/>
+            <a:off x="495300" y="7038975"/>
+            <a:ext cx="9705975" cy="9525"/>
+          </a:xfrm>
+          <a:prstGeom prst="rect">
+            <a:avLst/>
+          </a:prstGeom>
+          <a:solidFill>
+            <a:srgbClr val="E5E8F0"/>
+          </a:solidFill>
+          <a:ln/>
+        </p:spPr>
+      </p:sp>
+      <p:sp>
+        <p:nvSpPr>
+          <p:cNvPr id="30" name="Text 27"/>
+          <p:cNvSpPr/>
+          <p:nvPr/>
+        </p:nvSpPr>
+        <p:spPr>
+          <a:xfrm>
+            <a:off x="495300" y="7115175"/>
+            <a:ext cx="7639050" cy="157163"/>
           </a:xfrm>
           <a:prstGeom prst="rect">
             <a:avLst/>
@@ -28239,20 +29175,37 @@
           <a:p>
             <a:pPr algn="l" indent="0" marL="0">
               <a:lnSpc>
-                <a:spcPts val="1279"/>
+                <a:spcPts val="1238"/>
+              </a:lnSpc>
+              <a:buNone/>
+            </a:pPr>
+            <a:r>
+              <a:rPr lang="en-US" sz="850" b="1" dirty="0">
+                <a:solidFill>
+                  <a:srgbClr val="222C4F"/>
+                </a:solidFill>
+                <a:latin typeface="Lato" pitchFamily="34" charset="0"/>
+                <a:ea typeface="Lato" pitchFamily="34" charset="-122"/>
+                <a:cs typeface="Lato" pitchFamily="34" charset="-120"/>
+              </a:rPr>
+              <a:t>Elaborado por:</a:t>
+            </a:r>
+            <a:pPr algn="l" indent="0" marL="0">
+              <a:lnSpc>
+                <a:spcPts val="1238"/>
               </a:lnSpc>
               <a:buNone/>
             </a:pPr>
             <a:r>
               <a:rPr lang="en-US" sz="850" dirty="0">
                 <a:solidFill>
-                  <a:srgbClr val="5C6073"/>
+                  <a:srgbClr val="5A6072"/>
                 </a:solidFill>
                 <a:latin typeface="Lato" pitchFamily="34" charset="0"/>
                 <a:ea typeface="Lato" pitchFamily="34" charset="-122"/>
                 <a:cs typeface="Lato" pitchFamily="34" charset="-120"/>
               </a:rPr>
-              <a:t>SOFSA · Presupuesto 2027 · Subgerencia de Presupuesto y Control de Gestión · consultas: emmanuel.miranda@trenesargentinos.gob.ar · fabian.alvarez@trenesargentinos.gob.ar</a:t>
+              <a:t> Emmanuel Miranda, Fabián R. Álvarez · Gustavo Maida, Marlene Figueroa, Benjamín Sacido, Hernán Corro, Alejandra Quintana, Verónica Orosco</a:t>
             </a:r>
             <a:endParaRPr lang="en-US" sz="850" dirty="0"/>
           </a:p>
@@ -28260,14 +29213,14 @@
       </p:sp>
       <p:sp>
         <p:nvSpPr>
-          <p:cNvPr id="30" name="Text 27"/>
+          <p:cNvPr id="31" name="Text 28"/>
           <p:cNvSpPr/>
           <p:nvPr/>
         </p:nvSpPr>
         <p:spPr>
           <a:xfrm>
-            <a:off x="10010775" y="7267129"/>
-            <a:ext cx="628650" cy="162401"/>
+            <a:off x="495300" y="7272338"/>
+            <a:ext cx="7639050" cy="157163"/>
           </a:xfrm>
           <a:prstGeom prst="rect">
             <a:avLst/>
@@ -28281,7 +29234,66 @@
           <a:p>
             <a:pPr algn="l" indent="0" marL="0">
               <a:lnSpc>
-                <a:spcPts val="1279"/>
+                <a:spcPts val="1238"/>
+              </a:lnSpc>
+              <a:buNone/>
+            </a:pPr>
+            <a:r>
+              <a:rPr lang="en-US" sz="850" b="1" dirty="0">
+                <a:solidFill>
+                  <a:srgbClr val="222C4F"/>
+                </a:solidFill>
+                <a:latin typeface="Lato" pitchFamily="34" charset="0"/>
+                <a:ea typeface="Lato" pitchFamily="34" charset="-122"/>
+                <a:cs typeface="Lato" pitchFamily="34" charset="-120"/>
+              </a:rPr>
+              <a:t>Dudas/consultas:</a:t>
+            </a:r>
+            <a:pPr algn="l" indent="0" marL="0">
+              <a:lnSpc>
+                <a:spcPts val="1238"/>
+              </a:lnSpc>
+              <a:buNone/>
+            </a:pPr>
+            <a:r>
+              <a:rPr lang="en-US" sz="850" dirty="0">
+                <a:solidFill>
+                  <a:srgbClr val="5A6072"/>
+                </a:solidFill>
+                <a:latin typeface="Lato" pitchFamily="34" charset="0"/>
+                <a:ea typeface="Lato" pitchFamily="34" charset="-122"/>
+                <a:cs typeface="Lato" pitchFamily="34" charset="-120"/>
+              </a:rPr>
+              <a:t> emmanuel.miranda@trenesargentinos.gob.ar · fabian.alvarez@trenesargentinos.gob.ar</a:t>
+            </a:r>
+            <a:endParaRPr lang="en-US" sz="850" dirty="0"/>
+          </a:p>
+        </p:txBody>
+      </p:sp>
+      <p:sp>
+        <p:nvSpPr>
+          <p:cNvPr id="32" name="Text 29"/>
+          <p:cNvSpPr/>
+          <p:nvPr/>
+        </p:nvSpPr>
+        <p:spPr>
+          <a:xfrm>
+            <a:off x="8286750" y="7272338"/>
+            <a:ext cx="1914525" cy="157163"/>
+          </a:xfrm>
+          <a:prstGeom prst="rect">
+            <a:avLst/>
+          </a:prstGeom>
+          <a:noFill/>
+          <a:ln/>
+        </p:spPr>
+        <p:txBody>
+          <a:bodyPr wrap="none" lIns="0" tIns="0" rIns="0" bIns="0" rtlCol="0" anchor="t"/>
+          <a:lstStyle/>
+          <a:p>
+            <a:pPr algn="r" indent="0" marL="0">
+              <a:lnSpc>
+                <a:spcPts val="1238"/>
               </a:lnSpc>
               <a:buNone/>
             </a:pPr>
@@ -28294,7 +29306,7 @@
                 <a:ea typeface="Lato" pitchFamily="34" charset="-122"/>
                 <a:cs typeface="Lato" pitchFamily="34" charset="-120"/>
               </a:rPr>
-              <a:t>5 / 17</a:t>
+              <a:t>SOFSA · Presupuesto 2027 · 5 / 17</a:t>
             </a:r>
             <a:endParaRPr lang="en-US" sz="850" dirty="0"/>
           </a:p>
@@ -32654,14 +33666,34 @@
       </p:sp>
       <p:sp>
         <p:nvSpPr>
-          <p:cNvPr id="9" name="Text 6"/>
+          <p:cNvPr id="9" name="Shape 6"/>
           <p:cNvSpPr/>
           <p:nvPr/>
         </p:nvSpPr>
         <p:spPr>
           <a:xfrm>
-            <a:off x="438150" y="7267129"/>
-            <a:ext cx="8458200" cy="162401"/>
+            <a:off x="495300" y="7038975"/>
+            <a:ext cx="9705975" cy="9525"/>
+          </a:xfrm>
+          <a:prstGeom prst="rect">
+            <a:avLst/>
+          </a:prstGeom>
+          <a:solidFill>
+            <a:srgbClr val="E5E8F0"/>
+          </a:solidFill>
+          <a:ln/>
+        </p:spPr>
+      </p:sp>
+      <p:sp>
+        <p:nvSpPr>
+          <p:cNvPr id="10" name="Text 7"/>
+          <p:cNvSpPr/>
+          <p:nvPr/>
+        </p:nvSpPr>
+        <p:spPr>
+          <a:xfrm>
+            <a:off x="495300" y="7115175"/>
+            <a:ext cx="7639050" cy="157163"/>
           </a:xfrm>
           <a:prstGeom prst="rect">
             <a:avLst/>
@@ -32675,20 +33707,37 @@
           <a:p>
             <a:pPr algn="l" indent="0" marL="0">
               <a:lnSpc>
-                <a:spcPts val="1279"/>
+                <a:spcPts val="1238"/>
+              </a:lnSpc>
+              <a:buNone/>
+            </a:pPr>
+            <a:r>
+              <a:rPr lang="en-US" sz="850" b="1" dirty="0">
+                <a:solidFill>
+                  <a:srgbClr val="222C4F"/>
+                </a:solidFill>
+                <a:latin typeface="Lato" pitchFamily="34" charset="0"/>
+                <a:ea typeface="Lato" pitchFamily="34" charset="-122"/>
+                <a:cs typeface="Lato" pitchFamily="34" charset="-120"/>
+              </a:rPr>
+              <a:t>Elaborado por:</a:t>
+            </a:r>
+            <a:pPr algn="l" indent="0" marL="0">
+              <a:lnSpc>
+                <a:spcPts val="1238"/>
               </a:lnSpc>
               <a:buNone/>
             </a:pPr>
             <a:r>
               <a:rPr lang="en-US" sz="850" dirty="0">
                 <a:solidFill>
-                  <a:srgbClr val="5C6073"/>
+                  <a:srgbClr val="5A6072"/>
                 </a:solidFill>
                 <a:latin typeface="Lato" pitchFamily="34" charset="0"/>
                 <a:ea typeface="Lato" pitchFamily="34" charset="-122"/>
                 <a:cs typeface="Lato" pitchFamily="34" charset="-120"/>
               </a:rPr>
-              <a:t>SOFSA · Presupuesto 2027 · Subgerencia de Presupuesto y Control de Gestión · consultas: emmanuel.miranda@trenesargentinos.gob.ar · fabian.alvarez@trenesargentinos.gob.ar</a:t>
+              <a:t> Emmanuel Miranda, Fabián R. Álvarez · Gustavo Maida, Marlene Figueroa, Benjamín Sacido, Hernán Corro, Alejandra Quintana, Verónica Orosco</a:t>
             </a:r>
             <a:endParaRPr lang="en-US" sz="850" dirty="0"/>
           </a:p>
@@ -32696,14 +33745,14 @@
       </p:sp>
       <p:sp>
         <p:nvSpPr>
-          <p:cNvPr id="10" name="Text 7"/>
+          <p:cNvPr id="11" name="Text 8"/>
           <p:cNvSpPr/>
           <p:nvPr/>
         </p:nvSpPr>
         <p:spPr>
           <a:xfrm>
-            <a:off x="10010775" y="7267129"/>
-            <a:ext cx="628650" cy="162401"/>
+            <a:off x="495300" y="7272338"/>
+            <a:ext cx="7639050" cy="157163"/>
           </a:xfrm>
           <a:prstGeom prst="rect">
             <a:avLst/>
@@ -32717,7 +33766,66 @@
           <a:p>
             <a:pPr algn="l" indent="0" marL="0">
               <a:lnSpc>
-                <a:spcPts val="1279"/>
+                <a:spcPts val="1238"/>
+              </a:lnSpc>
+              <a:buNone/>
+            </a:pPr>
+            <a:r>
+              <a:rPr lang="en-US" sz="850" b="1" dirty="0">
+                <a:solidFill>
+                  <a:srgbClr val="222C4F"/>
+                </a:solidFill>
+                <a:latin typeface="Lato" pitchFamily="34" charset="0"/>
+                <a:ea typeface="Lato" pitchFamily="34" charset="-122"/>
+                <a:cs typeface="Lato" pitchFamily="34" charset="-120"/>
+              </a:rPr>
+              <a:t>Dudas/consultas:</a:t>
+            </a:r>
+            <a:pPr algn="l" indent="0" marL="0">
+              <a:lnSpc>
+                <a:spcPts val="1238"/>
+              </a:lnSpc>
+              <a:buNone/>
+            </a:pPr>
+            <a:r>
+              <a:rPr lang="en-US" sz="850" dirty="0">
+                <a:solidFill>
+                  <a:srgbClr val="5A6072"/>
+                </a:solidFill>
+                <a:latin typeface="Lato" pitchFamily="34" charset="0"/>
+                <a:ea typeface="Lato" pitchFamily="34" charset="-122"/>
+                <a:cs typeface="Lato" pitchFamily="34" charset="-120"/>
+              </a:rPr>
+              <a:t> emmanuel.miranda@trenesargentinos.gob.ar · fabian.alvarez@trenesargentinos.gob.ar</a:t>
+            </a:r>
+            <a:endParaRPr lang="en-US" sz="850" dirty="0"/>
+          </a:p>
+        </p:txBody>
+      </p:sp>
+      <p:sp>
+        <p:nvSpPr>
+          <p:cNvPr id="12" name="Text 9"/>
+          <p:cNvSpPr/>
+          <p:nvPr/>
+        </p:nvSpPr>
+        <p:spPr>
+          <a:xfrm>
+            <a:off x="8286750" y="7272338"/>
+            <a:ext cx="1914525" cy="157163"/>
+          </a:xfrm>
+          <a:prstGeom prst="rect">
+            <a:avLst/>
+          </a:prstGeom>
+          <a:noFill/>
+          <a:ln/>
+        </p:spPr>
+        <p:txBody>
+          <a:bodyPr wrap="none" lIns="0" tIns="0" rIns="0" bIns="0" rtlCol="0" anchor="t"/>
+          <a:lstStyle/>
+          <a:p>
+            <a:pPr algn="r" indent="0" marL="0">
+              <a:lnSpc>
+                <a:spcPts val="1238"/>
               </a:lnSpc>
               <a:buNone/>
             </a:pPr>
@@ -32730,7 +33838,7 @@
                 <a:ea typeface="Lato" pitchFamily="34" charset="-122"/>
                 <a:cs typeface="Lato" pitchFamily="34" charset="-120"/>
               </a:rPr>
-              <a:t>6 / 17</a:t>
+              <a:t>SOFSA · Presupuesto 2027 · 6 / 17</a:t>
             </a:r>
             <a:endParaRPr lang="en-US" sz="850" dirty="0"/>
           </a:p>
@@ -38375,14 +39483,34 @@
       </p:sp>
       <p:sp>
         <p:nvSpPr>
-          <p:cNvPr id="30" name="Text 26"/>
+          <p:cNvPr id="30" name="Shape 26"/>
           <p:cNvSpPr/>
           <p:nvPr/>
         </p:nvSpPr>
         <p:spPr>
           <a:xfrm>
-            <a:off x="438150" y="7267129"/>
-            <a:ext cx="8458200" cy="162401"/>
+            <a:off x="495300" y="7038975"/>
+            <a:ext cx="9705975" cy="9525"/>
+          </a:xfrm>
+          <a:prstGeom prst="rect">
+            <a:avLst/>
+          </a:prstGeom>
+          <a:solidFill>
+            <a:srgbClr val="E5E8F0"/>
+          </a:solidFill>
+          <a:ln/>
+        </p:spPr>
+      </p:sp>
+      <p:sp>
+        <p:nvSpPr>
+          <p:cNvPr id="31" name="Text 27"/>
+          <p:cNvSpPr/>
+          <p:nvPr/>
+        </p:nvSpPr>
+        <p:spPr>
+          <a:xfrm>
+            <a:off x="495300" y="7115175"/>
+            <a:ext cx="7639050" cy="157163"/>
           </a:xfrm>
           <a:prstGeom prst="rect">
             <a:avLst/>
@@ -38396,20 +39524,37 @@
           <a:p>
             <a:pPr algn="l" indent="0" marL="0">
               <a:lnSpc>
-                <a:spcPts val="1279"/>
+                <a:spcPts val="1238"/>
+              </a:lnSpc>
+              <a:buNone/>
+            </a:pPr>
+            <a:r>
+              <a:rPr lang="en-US" sz="850" b="1" dirty="0">
+                <a:solidFill>
+                  <a:srgbClr val="222C4F"/>
+                </a:solidFill>
+                <a:latin typeface="Lato" pitchFamily="34" charset="0"/>
+                <a:ea typeface="Lato" pitchFamily="34" charset="-122"/>
+                <a:cs typeface="Lato" pitchFamily="34" charset="-120"/>
+              </a:rPr>
+              <a:t>Elaborado por:</a:t>
+            </a:r>
+            <a:pPr algn="l" indent="0" marL="0">
+              <a:lnSpc>
+                <a:spcPts val="1238"/>
               </a:lnSpc>
               <a:buNone/>
             </a:pPr>
             <a:r>
               <a:rPr lang="en-US" sz="850" dirty="0">
                 <a:solidFill>
-                  <a:srgbClr val="5C6073"/>
+                  <a:srgbClr val="5A6072"/>
                 </a:solidFill>
                 <a:latin typeface="Lato" pitchFamily="34" charset="0"/>
                 <a:ea typeface="Lato" pitchFamily="34" charset="-122"/>
                 <a:cs typeface="Lato" pitchFamily="34" charset="-120"/>
               </a:rPr>
-              <a:t>SOFSA · Presupuesto 2027 · Subgerencia de Presupuesto y Control de Gestión · consultas: emmanuel.miranda@trenesargentinos.gob.ar · fabian.alvarez@trenesargentinos.gob.ar</a:t>
+              <a:t> Emmanuel Miranda, Fabián R. Álvarez · Gustavo Maida, Marlene Figueroa, Benjamín Sacido, Hernán Corro, Alejandra Quintana, Verónica Orosco</a:t>
             </a:r>
             <a:endParaRPr lang="en-US" sz="850" dirty="0"/>
           </a:p>
@@ -38417,14 +39562,14 @@
       </p:sp>
       <p:sp>
         <p:nvSpPr>
-          <p:cNvPr id="31" name="Text 27"/>
+          <p:cNvPr id="32" name="Text 28"/>
           <p:cNvSpPr/>
           <p:nvPr/>
         </p:nvSpPr>
         <p:spPr>
           <a:xfrm>
-            <a:off x="10010775" y="7267129"/>
-            <a:ext cx="628650" cy="162401"/>
+            <a:off x="495300" y="7272338"/>
+            <a:ext cx="7639050" cy="157163"/>
           </a:xfrm>
           <a:prstGeom prst="rect">
             <a:avLst/>
@@ -38438,7 +39583,66 @@
           <a:p>
             <a:pPr algn="l" indent="0" marL="0">
               <a:lnSpc>
-                <a:spcPts val="1279"/>
+                <a:spcPts val="1238"/>
+              </a:lnSpc>
+              <a:buNone/>
+            </a:pPr>
+            <a:r>
+              <a:rPr lang="en-US" sz="850" b="1" dirty="0">
+                <a:solidFill>
+                  <a:srgbClr val="222C4F"/>
+                </a:solidFill>
+                <a:latin typeface="Lato" pitchFamily="34" charset="0"/>
+                <a:ea typeface="Lato" pitchFamily="34" charset="-122"/>
+                <a:cs typeface="Lato" pitchFamily="34" charset="-120"/>
+              </a:rPr>
+              <a:t>Dudas/consultas:</a:t>
+            </a:r>
+            <a:pPr algn="l" indent="0" marL="0">
+              <a:lnSpc>
+                <a:spcPts val="1238"/>
+              </a:lnSpc>
+              <a:buNone/>
+            </a:pPr>
+            <a:r>
+              <a:rPr lang="en-US" sz="850" dirty="0">
+                <a:solidFill>
+                  <a:srgbClr val="5A6072"/>
+                </a:solidFill>
+                <a:latin typeface="Lato" pitchFamily="34" charset="0"/>
+                <a:ea typeface="Lato" pitchFamily="34" charset="-122"/>
+                <a:cs typeface="Lato" pitchFamily="34" charset="-120"/>
+              </a:rPr>
+              <a:t> emmanuel.miranda@trenesargentinos.gob.ar · fabian.alvarez@trenesargentinos.gob.ar</a:t>
+            </a:r>
+            <a:endParaRPr lang="en-US" sz="850" dirty="0"/>
+          </a:p>
+        </p:txBody>
+      </p:sp>
+      <p:sp>
+        <p:nvSpPr>
+          <p:cNvPr id="33" name="Text 29"/>
+          <p:cNvSpPr/>
+          <p:nvPr/>
+        </p:nvSpPr>
+        <p:spPr>
+          <a:xfrm>
+            <a:off x="8286750" y="7272338"/>
+            <a:ext cx="1914525" cy="157163"/>
+          </a:xfrm>
+          <a:prstGeom prst="rect">
+            <a:avLst/>
+          </a:prstGeom>
+          <a:noFill/>
+          <a:ln/>
+        </p:spPr>
+        <p:txBody>
+          <a:bodyPr wrap="none" lIns="0" tIns="0" rIns="0" bIns="0" rtlCol="0" anchor="t"/>
+          <a:lstStyle/>
+          <a:p>
+            <a:pPr algn="r" indent="0" marL="0">
+              <a:lnSpc>
+                <a:spcPts val="1238"/>
               </a:lnSpc>
               <a:buNone/>
             </a:pPr>
@@ -38451,7 +39655,7 @@
                 <a:ea typeface="Lato" pitchFamily="34" charset="-122"/>
                 <a:cs typeface="Lato" pitchFamily="34" charset="-120"/>
               </a:rPr>
-              <a:t>7 / 17</a:t>
+              <a:t>SOFSA · Presupuesto 2027 · 7 / 17</a:t>
             </a:r>
             <a:endParaRPr lang="en-US" sz="850" dirty="0"/>
           </a:p>
@@ -39667,14 +40871,34 @@
       </p:sp>
       <p:sp>
         <p:nvSpPr>
-          <p:cNvPr id="39" name="Text 36"/>
+          <p:cNvPr id="39" name="Shape 36"/>
           <p:cNvSpPr/>
           <p:nvPr/>
         </p:nvSpPr>
         <p:spPr>
           <a:xfrm>
-            <a:off x="438150" y="7267129"/>
-            <a:ext cx="8458200" cy="162401"/>
+            <a:off x="495300" y="7038975"/>
+            <a:ext cx="9705975" cy="9525"/>
+          </a:xfrm>
+          <a:prstGeom prst="rect">
+            <a:avLst/>
+          </a:prstGeom>
+          <a:solidFill>
+            <a:srgbClr val="E5E8F0"/>
+          </a:solidFill>
+          <a:ln/>
+        </p:spPr>
+      </p:sp>
+      <p:sp>
+        <p:nvSpPr>
+          <p:cNvPr id="40" name="Text 37"/>
+          <p:cNvSpPr/>
+          <p:nvPr/>
+        </p:nvSpPr>
+        <p:spPr>
+          <a:xfrm>
+            <a:off x="495300" y="7115175"/>
+            <a:ext cx="7639050" cy="157163"/>
           </a:xfrm>
           <a:prstGeom prst="rect">
             <a:avLst/>
@@ -39688,20 +40912,37 @@
           <a:p>
             <a:pPr algn="l" indent="0" marL="0">
               <a:lnSpc>
-                <a:spcPts val="1279"/>
+                <a:spcPts val="1238"/>
+              </a:lnSpc>
+              <a:buNone/>
+            </a:pPr>
+            <a:r>
+              <a:rPr lang="en-US" sz="850" b="1" dirty="0">
+                <a:solidFill>
+                  <a:srgbClr val="222C4F"/>
+                </a:solidFill>
+                <a:latin typeface="Lato" pitchFamily="34" charset="0"/>
+                <a:ea typeface="Lato" pitchFamily="34" charset="-122"/>
+                <a:cs typeface="Lato" pitchFamily="34" charset="-120"/>
+              </a:rPr>
+              <a:t>Elaborado por:</a:t>
+            </a:r>
+            <a:pPr algn="l" indent="0" marL="0">
+              <a:lnSpc>
+                <a:spcPts val="1238"/>
               </a:lnSpc>
               <a:buNone/>
             </a:pPr>
             <a:r>
               <a:rPr lang="en-US" sz="850" dirty="0">
                 <a:solidFill>
-                  <a:srgbClr val="5C6073"/>
+                  <a:srgbClr val="5A6072"/>
                 </a:solidFill>
                 <a:latin typeface="Lato" pitchFamily="34" charset="0"/>
                 <a:ea typeface="Lato" pitchFamily="34" charset="-122"/>
                 <a:cs typeface="Lato" pitchFamily="34" charset="-120"/>
               </a:rPr>
-              <a:t>SOFSA · Presupuesto 2027 · Subgerencia de Presupuesto y Control de Gestión · consultas: emmanuel.miranda@trenesargentinos.gob.ar · fabian.alvarez@trenesargentinos.gob.ar</a:t>
+              <a:t> Emmanuel Miranda, Fabián R. Álvarez · Gustavo Maida, Marlene Figueroa, Benjamín Sacido, Hernán Corro, Alejandra Quintana, Verónica Orosco</a:t>
             </a:r>
             <a:endParaRPr lang="en-US" sz="850" dirty="0"/>
           </a:p>
@@ -39709,14 +40950,14 @@
       </p:sp>
       <p:sp>
         <p:nvSpPr>
-          <p:cNvPr id="40" name="Text 37"/>
+          <p:cNvPr id="41" name="Text 38"/>
           <p:cNvSpPr/>
           <p:nvPr/>
         </p:nvSpPr>
         <p:spPr>
           <a:xfrm>
-            <a:off x="10010775" y="7267129"/>
-            <a:ext cx="628650" cy="162401"/>
+            <a:off x="495300" y="7272338"/>
+            <a:ext cx="7639050" cy="157163"/>
           </a:xfrm>
           <a:prstGeom prst="rect">
             <a:avLst/>
@@ -39730,7 +40971,66 @@
           <a:p>
             <a:pPr algn="l" indent="0" marL="0">
               <a:lnSpc>
-                <a:spcPts val="1279"/>
+                <a:spcPts val="1238"/>
+              </a:lnSpc>
+              <a:buNone/>
+            </a:pPr>
+            <a:r>
+              <a:rPr lang="en-US" sz="850" b="1" dirty="0">
+                <a:solidFill>
+                  <a:srgbClr val="222C4F"/>
+                </a:solidFill>
+                <a:latin typeface="Lato" pitchFamily="34" charset="0"/>
+                <a:ea typeface="Lato" pitchFamily="34" charset="-122"/>
+                <a:cs typeface="Lato" pitchFamily="34" charset="-120"/>
+              </a:rPr>
+              <a:t>Dudas/consultas:</a:t>
+            </a:r>
+            <a:pPr algn="l" indent="0" marL="0">
+              <a:lnSpc>
+                <a:spcPts val="1238"/>
+              </a:lnSpc>
+              <a:buNone/>
+            </a:pPr>
+            <a:r>
+              <a:rPr lang="en-US" sz="850" dirty="0">
+                <a:solidFill>
+                  <a:srgbClr val="5A6072"/>
+                </a:solidFill>
+                <a:latin typeface="Lato" pitchFamily="34" charset="0"/>
+                <a:ea typeface="Lato" pitchFamily="34" charset="-122"/>
+                <a:cs typeface="Lato" pitchFamily="34" charset="-120"/>
+              </a:rPr>
+              <a:t> emmanuel.miranda@trenesargentinos.gob.ar · fabian.alvarez@trenesargentinos.gob.ar</a:t>
+            </a:r>
+            <a:endParaRPr lang="en-US" sz="850" dirty="0"/>
+          </a:p>
+        </p:txBody>
+      </p:sp>
+      <p:sp>
+        <p:nvSpPr>
+          <p:cNvPr id="42" name="Text 39"/>
+          <p:cNvSpPr/>
+          <p:nvPr/>
+        </p:nvSpPr>
+        <p:spPr>
+          <a:xfrm>
+            <a:off x="8286750" y="7272338"/>
+            <a:ext cx="1914525" cy="157163"/>
+          </a:xfrm>
+          <a:prstGeom prst="rect">
+            <a:avLst/>
+          </a:prstGeom>
+          <a:noFill/>
+          <a:ln/>
+        </p:spPr>
+        <p:txBody>
+          <a:bodyPr wrap="none" lIns="0" tIns="0" rIns="0" bIns="0" rtlCol="0" anchor="t"/>
+          <a:lstStyle/>
+          <a:p>
+            <a:pPr algn="r" indent="0" marL="0">
+              <a:lnSpc>
+                <a:spcPts val="1238"/>
               </a:lnSpc>
               <a:buNone/>
             </a:pPr>
@@ -39743,7 +41043,7 @@
                 <a:ea typeface="Lato" pitchFamily="34" charset="-122"/>
                 <a:cs typeface="Lato" pitchFamily="34" charset="-120"/>
               </a:rPr>
-              <a:t>8 / 17</a:t>
+              <a:t>SOFSA · Presupuesto 2027 · 8 / 17</a:t>
             </a:r>
             <a:endParaRPr lang="en-US" sz="850" dirty="0"/>
           </a:p>
@@ -42814,14 +44114,34 @@
       </p:sp>
       <p:sp>
         <p:nvSpPr>
-          <p:cNvPr id="9" name="Text 6"/>
+          <p:cNvPr id="9" name="Shape 6"/>
           <p:cNvSpPr/>
           <p:nvPr/>
         </p:nvSpPr>
         <p:spPr>
           <a:xfrm>
-            <a:off x="438150" y="7267129"/>
-            <a:ext cx="8458200" cy="162401"/>
+            <a:off x="495300" y="7038975"/>
+            <a:ext cx="9705975" cy="9525"/>
+          </a:xfrm>
+          <a:prstGeom prst="rect">
+            <a:avLst/>
+          </a:prstGeom>
+          <a:solidFill>
+            <a:srgbClr val="E5E8F0"/>
+          </a:solidFill>
+          <a:ln/>
+        </p:spPr>
+      </p:sp>
+      <p:sp>
+        <p:nvSpPr>
+          <p:cNvPr id="10" name="Text 7"/>
+          <p:cNvSpPr/>
+          <p:nvPr/>
+        </p:nvSpPr>
+        <p:spPr>
+          <a:xfrm>
+            <a:off x="495300" y="7115175"/>
+            <a:ext cx="7639050" cy="157163"/>
           </a:xfrm>
           <a:prstGeom prst="rect">
             <a:avLst/>
@@ -42835,20 +44155,37 @@
           <a:p>
             <a:pPr algn="l" indent="0" marL="0">
               <a:lnSpc>
-                <a:spcPts val="1279"/>
+                <a:spcPts val="1238"/>
+              </a:lnSpc>
+              <a:buNone/>
+            </a:pPr>
+            <a:r>
+              <a:rPr lang="en-US" sz="850" b="1" dirty="0">
+                <a:solidFill>
+                  <a:srgbClr val="222C4F"/>
+                </a:solidFill>
+                <a:latin typeface="Lato" pitchFamily="34" charset="0"/>
+                <a:ea typeface="Lato" pitchFamily="34" charset="-122"/>
+                <a:cs typeface="Lato" pitchFamily="34" charset="-120"/>
+              </a:rPr>
+              <a:t>Elaborado por:</a:t>
+            </a:r>
+            <a:pPr algn="l" indent="0" marL="0">
+              <a:lnSpc>
+                <a:spcPts val="1238"/>
               </a:lnSpc>
               <a:buNone/>
             </a:pPr>
             <a:r>
               <a:rPr lang="en-US" sz="850" dirty="0">
                 <a:solidFill>
-                  <a:srgbClr val="5C6073"/>
+                  <a:srgbClr val="5A6072"/>
                 </a:solidFill>
                 <a:latin typeface="Lato" pitchFamily="34" charset="0"/>
                 <a:ea typeface="Lato" pitchFamily="34" charset="-122"/>
                 <a:cs typeface="Lato" pitchFamily="34" charset="-120"/>
               </a:rPr>
-              <a:t>SOFSA · Presupuesto 2027 · Subgerencia de Presupuesto y Control de Gestión · consultas: emmanuel.miranda@trenesargentinos.gob.ar · fabian.alvarez@trenesargentinos.gob.ar</a:t>
+              <a:t> Emmanuel Miranda, Fabián R. Álvarez · Gustavo Maida, Marlene Figueroa, Benjamín Sacido, Hernán Corro, Alejandra Quintana, Verónica Orosco</a:t>
             </a:r>
             <a:endParaRPr lang="en-US" sz="850" dirty="0"/>
           </a:p>
@@ -42856,14 +44193,14 @@
       </p:sp>
       <p:sp>
         <p:nvSpPr>
-          <p:cNvPr id="10" name="Text 7"/>
+          <p:cNvPr id="11" name="Text 8"/>
           <p:cNvSpPr/>
           <p:nvPr/>
         </p:nvSpPr>
         <p:spPr>
           <a:xfrm>
-            <a:off x="10010775" y="7267129"/>
-            <a:ext cx="628650" cy="162401"/>
+            <a:off x="495300" y="7272338"/>
+            <a:ext cx="7639050" cy="157163"/>
           </a:xfrm>
           <a:prstGeom prst="rect">
             <a:avLst/>
@@ -42877,7 +44214,66 @@
           <a:p>
             <a:pPr algn="l" indent="0" marL="0">
               <a:lnSpc>
-                <a:spcPts val="1279"/>
+                <a:spcPts val="1238"/>
+              </a:lnSpc>
+              <a:buNone/>
+            </a:pPr>
+            <a:r>
+              <a:rPr lang="en-US" sz="850" b="1" dirty="0">
+                <a:solidFill>
+                  <a:srgbClr val="222C4F"/>
+                </a:solidFill>
+                <a:latin typeface="Lato" pitchFamily="34" charset="0"/>
+                <a:ea typeface="Lato" pitchFamily="34" charset="-122"/>
+                <a:cs typeface="Lato" pitchFamily="34" charset="-120"/>
+              </a:rPr>
+              <a:t>Dudas/consultas:</a:t>
+            </a:r>
+            <a:pPr algn="l" indent="0" marL="0">
+              <a:lnSpc>
+                <a:spcPts val="1238"/>
+              </a:lnSpc>
+              <a:buNone/>
+            </a:pPr>
+            <a:r>
+              <a:rPr lang="en-US" sz="850" dirty="0">
+                <a:solidFill>
+                  <a:srgbClr val="5A6072"/>
+                </a:solidFill>
+                <a:latin typeface="Lato" pitchFamily="34" charset="0"/>
+                <a:ea typeface="Lato" pitchFamily="34" charset="-122"/>
+                <a:cs typeface="Lato" pitchFamily="34" charset="-120"/>
+              </a:rPr>
+              <a:t> emmanuel.miranda@trenesargentinos.gob.ar · fabian.alvarez@trenesargentinos.gob.ar</a:t>
+            </a:r>
+            <a:endParaRPr lang="en-US" sz="850" dirty="0"/>
+          </a:p>
+        </p:txBody>
+      </p:sp>
+      <p:sp>
+        <p:nvSpPr>
+          <p:cNvPr id="12" name="Text 9"/>
+          <p:cNvSpPr/>
+          <p:nvPr/>
+        </p:nvSpPr>
+        <p:spPr>
+          <a:xfrm>
+            <a:off x="8286750" y="7272338"/>
+            <a:ext cx="1914525" cy="157163"/>
+          </a:xfrm>
+          <a:prstGeom prst="rect">
+            <a:avLst/>
+          </a:prstGeom>
+          <a:noFill/>
+          <a:ln/>
+        </p:spPr>
+        <p:txBody>
+          <a:bodyPr wrap="none" lIns="0" tIns="0" rIns="0" bIns="0" rtlCol="0" anchor="t"/>
+          <a:lstStyle/>
+          <a:p>
+            <a:pPr algn="r" indent="0" marL="0">
+              <a:lnSpc>
+                <a:spcPts val="1238"/>
               </a:lnSpc>
               <a:buNone/>
             </a:pPr>
@@ -42890,7 +44286,7 @@
                 <a:ea typeface="Lato" pitchFamily="34" charset="-122"/>
                 <a:cs typeface="Lato" pitchFamily="34" charset="-120"/>
               </a:rPr>
-              <a:t>9 / 17</a:t>
+              <a:t>SOFSA · Presupuesto 2027 · 9 / 17</a:t>
             </a:r>
             <a:endParaRPr lang="en-US" sz="850" dirty="0"/>
           </a:p>

</xml_diff>